<commit_message>
Integrate OOD generalization results into analysis deck
Adds a '심화: 일반화(OOD) 검증' section (6 slides) using the real
robustness experiment numbers: base model collapses on unseen warmer
climate (PRECC R2 -0.12) while relative-humidity features stay positive
(+0.21), with seed-stability and honest limitations (distribution-shift
framing, control-group caveat, Beucler 2024 link).

Co-Authored-By: Claude Opus 4.8 <noreply@anthropic.com>
Claude-Session: https://claude.ai/code/session_01XSv1AQXs1ufUZR8MGQ2LAd
</commit_message>
<xml_diff>
--- a/presentations/ClimSim_전처리분석.pptx
+++ b/presentations/ClimSim_전처리분석.pptx
@@ -46,9 +46,15 @@
     <p:sldId id="294" r:id="rId40"/>
     <p:sldId id="295" r:id="rId41"/>
     <p:sldId id="296" r:id="rId42"/>
+    <p:sldId id="297" r:id="rId43"/>
+    <p:sldId id="298" r:id="rId44"/>
+    <p:sldId id="299" r:id="rId45"/>
+    <p:sldId id="300" r:id="rId46"/>
+    <p:sldId id="301" r:id="rId47"/>
+    <p:sldId id="302" r:id="rId48"/>
   </p:sldIdLst>
   <p:notesMasterIdLst>
-    <p:notesMasterId r:id="rId43"/>
+    <p:notesMasterId r:id="rId49"/>
   </p:notesMasterIdLst>
   <p:sldSz cx="12188952" cy="6858000"/>
   <p:notesSz cx="6858000" cy="12188952"/>
@@ -3270,7 +3276,7 @@
           <a:p>
             <a:r>
               <a:rPr lang="en-US" dirty="0"/>
-              <a:t>이제 전체를 마무리합니다. 오늘 파이프라인에서 얻은 교훈을 정리하고, 이 모든 과정을 누구나 재현할 수 있도록 정리한 스크립트들을 소개합니다.</a:t>
+              <a:t>여기까지가 표준 파이프라인이었습니다. 하지만 진짜 시험은 따로 있습니다. 미래 기후 예측은 결국 '본 적 없는 더운 상태'를 맞히는 외삽 문제입니다. 그래서 시원한 쪽으로만 학습하고, 일부러 빼놓은 더운 조건에서 소나기 예측이 버티는지를 검증했습니다. 이 심화 실험이 특성 공학이 '왜' 중요한지의 궁극적 증거가 됩니다.</a:t>
             </a:r>
             <a:endParaRPr lang="en-US" dirty="0"/>
           </a:p>
@@ -3358,7 +3364,7 @@
           <a:p>
             <a:r>
               <a:rPr lang="en-US" dirty="0"/>
-              <a:t>파이프라인이 준 세 가지 교훈입니다. 첫째, 데이터를 먼저 봅니다. 품질 점검과 이상치 파악을 건너뛰면, 나중에 나온 지표를 오해하게 됩니다. 우리가 두꺼운 꼬리를 미리 봤기에 음수 R2를 이해할 수 있었죠. 둘째, 지표를 올바로 고릅니다. 단순평균 R2의 함정에 빠지지 말고, 분산가중 R2와 그룹별 평가를 함께 봐야 합니다. 셋째이자 가장 중요한 것, 변수가 모델을 이깁니다. 물리 기반 파생변수, 특히 비선형 항을 넣는 것이 모델을 복잡하게 바꾸는 것보다 효과적이었습니다. 이 세 교훈은 ClimSim만이 아니라 거의 모든 데이터 분석에 적용됩니다.</a:t>
+              <a:t>표준 파이프라인의 R²는 모두 IID, 즉 학습과 같은 분포에서의 성능이었습니다. 하지만 진짜 시험은 외삽입니다. 미래 온난화를 예측한다는 건 본 적 없는 더운 상태를 맞히는 일이니까요. 이건 모델이 데이터를 단순히 외웠는지, 아니면 관계를 이해했는지를 가르는 시험입니다. 설계는 이렇습니다. 시원한 쪽 기온으로만 학습하고, 일부러 빼놓은 더운 밴드 세 개에서 시험합니다. 지표는 가장 어려운 소나기, 대류성 강수 PRECC입니다. 그리고 기본 입력과 상대습도를 넣은 입력을 비교하되, 우연이 아님을 확인하려고 seed를 5번 바꿔 반복했습니다. 다음 장에서 설계를 그림으로 봅니다.</a:t>
             </a:r>
             <a:endParaRPr lang="en-US" dirty="0"/>
           </a:p>
@@ -3534,7 +3540,7 @@
           <a:p>
             <a:r>
               <a:rPr lang="en-US" dirty="0"/>
-              <a:t>이 모든 과정은 재현 가능하도록 스크립트로 정리했습니다. download_subsampled.py로 데이터를 받고, check_data_quality.py로 품질을 점검합니다. climsim_model_comparison.py가 세 모델을 비교하고 지표로 평가하며, climsim_domain_features.py가 물리 파생변수로 개선을 시도합니다. VARIABLES.md는 변수 참고 문서입니다. 모든 스크립트는 고정 seed와 명령행 옵션을 갖추고 있어서, 누구나 같은 명령으로 같은 결과를 재현할 수 있습니다. 재현성은 좋은 데이터 분석의 기본입니다. 이걸로 오늘 파이프라인을 마칩니다.</a:t>
+              <a:t>실험 설계를 그림으로 봅니다. 가로축은 지표기온입니다. 왼쪽 파란 영역, 시원한 절반(평균 278K)으로만 모델을 학습시킵니다. 그리고 오른쪽의 더운 세 구간 — 조금 더움 +17도, 꽤 더움 +21도, 가장 더움 +26도 — 은 학습에서 완전히 빼놓고 시험합니다. 즉 모델은 이 더운 상태를 한 번도 본 적이 없습니다. 이렇게 얼마나 더 더운 조건까지 밀어붙이는지를 단계로 보는 외삽 스트레스 테스트입니다. 한 가지 정직하게 짚으면, 이 온도 구간은 실제 온난화(+3~4도)라기보다 지역·계절 차이가 큰 분포 이동에 가깝습니다. 그래도 '더 멀수록 무너지는가'라는 방향성을 보는 데는 딱 맞습니다. 결과를 봅니다.</a:t>
             </a:r>
             <a:endParaRPr lang="en-US" dirty="0"/>
           </a:p>
@@ -3622,7 +3628,7 @@
           <a:p>
             <a:r>
               <a:rPr lang="en-US" dirty="0"/>
-              <a:t>마무리하겠습니다. 오늘 우리는 데이터를 받는 것부터 품질 점검, 전처리, 모델링, 평가, 특성 공학까지 하나의 파이프라인을 따라왔습니다. 가장 큰 배움은 이것입니다. 좋은 분석은 좋은 모델에서 나오는 게 아니라, 좋은 질문과 정직한 평가에서 나온다. 데이터를 먼저 이해하고, 겉보기 지표를 의심하고, 물리 지식으로 변수를 만드는 것. 이 태도가 화려한 모델보다 결과를 더 크게 바꿨습니다. 이 관점을 가지고 데이터를 대하면, 어떤 문제에서도 숫자 너머의 진실을 볼 수 있을 것입니다. 감사합니다.</a:t>
+              <a:t>이것이 이 탐구의 핵심 결과입니다. 가로축은 얼마나 더 더운 조건인지, 세로축은 소나기 예측 R²입니다. 0 아래면 평균 찍기보다 못한 것입니다. 두 선을 보세요. 같은 날씨에서는 둘 다 높지만, 오른쪽으로 갈수록 파란 선, 기본 입력이 급격히 떨어져 가장 더운 밴드에서 마이너스 0.12로 0 아래로 붕괴합니다. 게다가 오차막대가 커서 불안정합니다. 반면 주황 선, 상대습도를 넣은 모델은 플러스 0.21로 양수를 유지하고 오차막대도 작습니다. 두 신뢰구간이 겹치지 않아 통계적으로도 뚜렷한 차이입니다. 즉 물리 변수 하나가, 배운 적 없는 더운 기후에서 무너지던 예측을 되살린 것입니다. 다음 장에서 이게 우연이 아님을 seed별로 확인합니다.</a:t>
             </a:r>
             <a:endParaRPr lang="en-US" dirty="0"/>
           </a:p>
@@ -3646,6 +3652,534 @@
             <a:fld id="{F7021451-1387-4CA6-816F-3879F97B5CBC}" type="slidenum">
               <a:rPr lang="en-US"/>
               <a:t>41</a:t>
+            </a:fld>
+            <a:endParaRPr lang="en-US"/>
+          </a:p>
+        </p:txBody>
+      </p:sp>
+    </p:spTree>
+    <p:extLst>
+      <p:ext uri="{BB962C8B-B14F-4D97-AF65-F5344CB8AC3E}">
+        <p14:creationId xmlns:p14="http://schemas.microsoft.com/office/powerpoint/2010/main" val="1024086991"/>
+      </p:ext>
+    </p:extLst>
+  </p:cSld>
+  <p:clrMapOvr>
+    <a:masterClrMapping/>
+  </p:clrMapOvr>
+</p:notes>
+</file>
+
+<file path=ppt/notesSlides/notesSlide42.xml><?xml version="1.0" encoding="utf-8"?>
+<p:notes xmlns:a="http://schemas.openxmlformats.org/drawingml/2006/main" xmlns:r="http://schemas.openxmlformats.org/officeDocument/2006/relationships" xmlns:p="http://schemas.openxmlformats.org/presentationml/2006/main">
+  <p:cSld>
+    <p:spTree>
+      <p:nvGrpSpPr>
+        <p:cNvPr id="1" name=""/>
+        <p:cNvGrpSpPr/>
+        <p:nvPr/>
+      </p:nvGrpSpPr>
+      <p:grpSpPr>
+        <a:xfrm>
+          <a:off x="0" y="0"/>
+          <a:ext cx="0" cy="0"/>
+          <a:chOff x="0" y="0"/>
+          <a:chExt cx="0" cy="0"/>
+        </a:xfrm>
+      </p:grpSpPr>
+      <p:sp>
+        <p:nvSpPr>
+          <p:cNvPr id="2" name="Slide Image Placeholder 1"/>
+          <p:cNvSpPr>
+            <a:spLocks noGrp="1" noRot="1" noChangeAspect="1"/>
+          </p:cNvSpPr>
+          <p:nvPr>
+            <p:ph type="sldImg"/>
+          </p:nvPr>
+        </p:nvSpPr>
+        <p:spPr/>
+      </p:sp>
+      <p:sp>
+        <p:nvSpPr>
+          <p:cNvPr id="3" name="Notes Placeholder 2"/>
+          <p:cNvSpPr>
+            <a:spLocks noGrp="1"/>
+          </p:cNvSpPr>
+          <p:nvPr>
+            <p:ph type="body" idx="1"/>
+          </p:nvPr>
+        </p:nvSpPr>
+        <p:spPr/>
+        <p:txBody>
+          <a:bodyPr/>
+          <a:lstStyle/>
+          <a:p>
+            <a:r>
+              <a:rPr lang="en-US" dirty="0"/>
+              <a:t>결과가 우연이 아님을 seed별로 봅니다. 왼쪽 그림에서 가장 더운 밴드의 5번 반복을 점으로 찍었습니다. 파란 점, 기본 입력은 0을 위아래로 넘나듭니다. 특히 한 seed는 마이너스 0.35까지 떨어졌죠. 즉 기본 모델은 더운 기후에서 예측이 될 때도 안 될 때도 있는, 믿을 수 없는 상태입니다. 반면 주황 점, 상대습도는 다섯 번 모두 양수이고 뭉쳐 있습니다. 아래 표는 전체 요약입니다. 같은 날씨에서 +17, +21도까지는 두 방법이 비슷하지만, 가장 더운 +26도에서 기본은 마이너스로 무너지고 RH는 플러스 0.21로 버팁니다. 반복해도 이 차이가 유지된다는 것이 핵심입니다.</a:t>
+            </a:r>
+            <a:endParaRPr lang="en-US" dirty="0"/>
+          </a:p>
+        </p:txBody>
+      </p:sp>
+      <p:sp>
+        <p:nvSpPr>
+          <p:cNvPr id="4" name="Slide Number Placeholder 3"/>
+          <p:cNvSpPr>
+            <a:spLocks noGrp="1"/>
+          </p:cNvSpPr>
+          <p:nvPr>
+            <p:ph type="sldNum" sz="quarter" idx="10"/>
+          </p:nvPr>
+        </p:nvSpPr>
+        <p:spPr/>
+        <p:txBody>
+          <a:bodyPr/>
+          <a:lstStyle/>
+          <a:p>
+            <a:fld id="{F7021451-1387-4CA6-816F-3879F97B5CBC}" type="slidenum">
+              <a:rPr lang="en-US"/>
+              <a:t>42</a:t>
+            </a:fld>
+            <a:endParaRPr lang="en-US"/>
+          </a:p>
+        </p:txBody>
+      </p:sp>
+    </p:spTree>
+    <p:extLst>
+      <p:ext uri="{BB962C8B-B14F-4D97-AF65-F5344CB8AC3E}">
+        <p14:creationId xmlns:p14="http://schemas.microsoft.com/office/powerpoint/2010/main" val="1024086991"/>
+      </p:ext>
+    </p:extLst>
+  </p:cSld>
+  <p:clrMapOvr>
+    <a:masterClrMapping/>
+  </p:clrMapOvr>
+</p:notes>
+</file>
+
+<file path=ppt/notesSlides/notesSlide43.xml><?xml version="1.0" encoding="utf-8"?>
+<p:notes xmlns:a="http://schemas.openxmlformats.org/drawingml/2006/main" xmlns:r="http://schemas.openxmlformats.org/officeDocument/2006/relationships" xmlns:p="http://schemas.openxmlformats.org/presentationml/2006/main">
+  <p:cSld>
+    <p:spTree>
+      <p:nvGrpSpPr>
+        <p:cNvPr id="1" name=""/>
+        <p:cNvGrpSpPr/>
+        <p:nvPr/>
+      </p:nvGrpSpPr>
+      <p:grpSpPr>
+        <a:xfrm>
+          <a:off x="0" y="0"/>
+          <a:ext cx="0" cy="0"/>
+          <a:chOff x="0" y="0"/>
+          <a:chExt cx="0" cy="0"/>
+        </a:xfrm>
+      </p:grpSpPr>
+      <p:sp>
+        <p:nvSpPr>
+          <p:cNvPr id="2" name="Slide Image Placeholder 1"/>
+          <p:cNvSpPr>
+            <a:spLocks noGrp="1" noRot="1" noChangeAspect="1"/>
+          </p:cNvSpPr>
+          <p:nvPr>
+            <p:ph type="sldImg"/>
+          </p:nvPr>
+        </p:nvSpPr>
+        <p:spPr/>
+      </p:sp>
+      <p:sp>
+        <p:nvSpPr>
+          <p:cNvPr id="3" name="Notes Placeholder 2"/>
+          <p:cNvSpPr>
+            <a:spLocks noGrp="1"/>
+          </p:cNvSpPr>
+          <p:nvPr>
+            <p:ph type="body" idx="1"/>
+          </p:nvPr>
+        </p:nvSpPr>
+        <p:spPr/>
+        <p:txBody>
+          <a:bodyPr/>
+          <a:lstStyle/>
+          <a:p>
+            <a:r>
+              <a:rPr lang="en-US" dirty="0"/>
+              <a:t>왜 상대습도가 버틸까요? 상대습도는 수증기를 '그 기온에서 담을 수 있는 최대치'로 나눈 비율입니다. 기온이 올라가면 절대 수증기량도 최대 수용량도 함께 늘어나기 때문에, 그 비율 관계는 기후가 바뀌어도 잘 변하지 않습니다. 이걸 기후 불변, climate-invariant라고 부릅니다. 그래서 더운 기후로 외삽해도 예측이 이어집니다. 물리를 변수에 미리 새겨 넣은 것이죠. 오른쪽은 정직한 한계입니다. 첫째, 온도밴드는 실제 온난화라기보다 지역·계절 분포 이동에 가까워서, 이건 방향성을 보는 실험입니다. 둘째, RH는 습도에서 강수로 가는 경로만 살리고 전체 수증기 경향은 여전히 낮습니다. 셋째, seed가 5개라 더 늘리면 좋고, 비물리 대조군을 추가하면 'RH라서 된다'는 인과가 확실해집니다. 그럼에도 이 결과의 방향은 Beucler의 2024년 기후 불변 머신러닝 연구와 정확히 일치합니다. 축소 데이터로 큰 연구 흐름을 직접 재현한 셈입니다.</a:t>
+            </a:r>
+            <a:endParaRPr lang="en-US" dirty="0"/>
+          </a:p>
+        </p:txBody>
+      </p:sp>
+      <p:sp>
+        <p:nvSpPr>
+          <p:cNvPr id="4" name="Slide Number Placeholder 3"/>
+          <p:cNvSpPr>
+            <a:spLocks noGrp="1"/>
+          </p:cNvSpPr>
+          <p:nvPr>
+            <p:ph type="sldNum" sz="quarter" idx="10"/>
+          </p:nvPr>
+        </p:nvSpPr>
+        <p:spPr/>
+        <p:txBody>
+          <a:bodyPr/>
+          <a:lstStyle/>
+          <a:p>
+            <a:fld id="{F7021451-1387-4CA6-816F-3879F97B5CBC}" type="slidenum">
+              <a:rPr lang="en-US"/>
+              <a:t>43</a:t>
+            </a:fld>
+            <a:endParaRPr lang="en-US"/>
+          </a:p>
+        </p:txBody>
+      </p:sp>
+    </p:spTree>
+    <p:extLst>
+      <p:ext uri="{BB962C8B-B14F-4D97-AF65-F5344CB8AC3E}">
+        <p14:creationId xmlns:p14="http://schemas.microsoft.com/office/powerpoint/2010/main" val="1024086991"/>
+      </p:ext>
+    </p:extLst>
+  </p:cSld>
+  <p:clrMapOvr>
+    <a:masterClrMapping/>
+  </p:clrMapOvr>
+</p:notes>
+</file>
+
+<file path=ppt/notesSlides/notesSlide44.xml><?xml version="1.0" encoding="utf-8"?>
+<p:notes xmlns:a="http://schemas.openxmlformats.org/drawingml/2006/main" xmlns:r="http://schemas.openxmlformats.org/officeDocument/2006/relationships" xmlns:p="http://schemas.openxmlformats.org/presentationml/2006/main">
+  <p:cSld>
+    <p:spTree>
+      <p:nvGrpSpPr>
+        <p:cNvPr id="1" name=""/>
+        <p:cNvGrpSpPr/>
+        <p:nvPr/>
+      </p:nvGrpSpPr>
+      <p:grpSpPr>
+        <a:xfrm>
+          <a:off x="0" y="0"/>
+          <a:ext cx="0" cy="0"/>
+          <a:chOff x="0" y="0"/>
+          <a:chExt cx="0" cy="0"/>
+        </a:xfrm>
+      </p:grpSpPr>
+      <p:sp>
+        <p:nvSpPr>
+          <p:cNvPr id="2" name="Slide Image Placeholder 1"/>
+          <p:cNvSpPr>
+            <a:spLocks noGrp="1" noRot="1" noChangeAspect="1"/>
+          </p:cNvSpPr>
+          <p:nvPr>
+            <p:ph type="sldImg"/>
+          </p:nvPr>
+        </p:nvSpPr>
+        <p:spPr/>
+      </p:sp>
+      <p:sp>
+        <p:nvSpPr>
+          <p:cNvPr id="3" name="Notes Placeholder 2"/>
+          <p:cNvSpPr>
+            <a:spLocks noGrp="1"/>
+          </p:cNvSpPr>
+          <p:nvPr>
+            <p:ph type="body" idx="1"/>
+          </p:nvPr>
+        </p:nvSpPr>
+        <p:spPr/>
+        <p:txBody>
+          <a:bodyPr/>
+          <a:lstStyle/>
+          <a:p>
+            <a:r>
+              <a:rPr lang="en-US" dirty="0"/>
+              <a:t>이제 전체를 마무리합니다. 오늘 파이프라인에서 얻은 교훈을 정리하고, 이 모든 과정을 누구나 재현할 수 있도록 정리한 스크립트들을 소개합니다.</a:t>
+            </a:r>
+            <a:endParaRPr lang="en-US" dirty="0"/>
+          </a:p>
+        </p:txBody>
+      </p:sp>
+      <p:sp>
+        <p:nvSpPr>
+          <p:cNvPr id="4" name="Slide Number Placeholder 3"/>
+          <p:cNvSpPr>
+            <a:spLocks noGrp="1"/>
+          </p:cNvSpPr>
+          <p:nvPr>
+            <p:ph type="sldNum" sz="quarter" idx="10"/>
+          </p:nvPr>
+        </p:nvSpPr>
+        <p:spPr/>
+        <p:txBody>
+          <a:bodyPr/>
+          <a:lstStyle/>
+          <a:p>
+            <a:fld id="{F7021451-1387-4CA6-816F-3879F97B5CBC}" type="slidenum">
+              <a:rPr lang="en-US"/>
+              <a:t>44</a:t>
+            </a:fld>
+            <a:endParaRPr lang="en-US"/>
+          </a:p>
+        </p:txBody>
+      </p:sp>
+    </p:spTree>
+    <p:extLst>
+      <p:ext uri="{BB962C8B-B14F-4D97-AF65-F5344CB8AC3E}">
+        <p14:creationId xmlns:p14="http://schemas.microsoft.com/office/powerpoint/2010/main" val="1024086991"/>
+      </p:ext>
+    </p:extLst>
+  </p:cSld>
+  <p:clrMapOvr>
+    <a:masterClrMapping/>
+  </p:clrMapOvr>
+</p:notes>
+</file>
+
+<file path=ppt/notesSlides/notesSlide45.xml><?xml version="1.0" encoding="utf-8"?>
+<p:notes xmlns:a="http://schemas.openxmlformats.org/drawingml/2006/main" xmlns:r="http://schemas.openxmlformats.org/officeDocument/2006/relationships" xmlns:p="http://schemas.openxmlformats.org/presentationml/2006/main">
+  <p:cSld>
+    <p:spTree>
+      <p:nvGrpSpPr>
+        <p:cNvPr id="1" name=""/>
+        <p:cNvGrpSpPr/>
+        <p:nvPr/>
+      </p:nvGrpSpPr>
+      <p:grpSpPr>
+        <a:xfrm>
+          <a:off x="0" y="0"/>
+          <a:ext cx="0" cy="0"/>
+          <a:chOff x="0" y="0"/>
+          <a:chExt cx="0" cy="0"/>
+        </a:xfrm>
+      </p:grpSpPr>
+      <p:sp>
+        <p:nvSpPr>
+          <p:cNvPr id="2" name="Slide Image Placeholder 1"/>
+          <p:cNvSpPr>
+            <a:spLocks noGrp="1" noRot="1" noChangeAspect="1"/>
+          </p:cNvSpPr>
+          <p:nvPr>
+            <p:ph type="sldImg"/>
+          </p:nvPr>
+        </p:nvSpPr>
+        <p:spPr/>
+      </p:sp>
+      <p:sp>
+        <p:nvSpPr>
+          <p:cNvPr id="3" name="Notes Placeholder 2"/>
+          <p:cNvSpPr>
+            <a:spLocks noGrp="1"/>
+          </p:cNvSpPr>
+          <p:nvPr>
+            <p:ph type="body" idx="1"/>
+          </p:nvPr>
+        </p:nvSpPr>
+        <p:spPr/>
+        <p:txBody>
+          <a:bodyPr/>
+          <a:lstStyle/>
+          <a:p>
+            <a:r>
+              <a:rPr lang="en-US" dirty="0"/>
+              <a:t>파이프라인이 준 세 가지 교훈입니다. 첫째, 데이터를 먼저 봅니다. 품질 점검과 이상치 파악을 건너뛰면, 나중에 나온 지표를 오해하게 됩니다. 우리가 두꺼운 꼬리를 미리 봤기에 음수 R2를 이해할 수 있었죠. 둘째, 지표를 올바로 고릅니다. 단순평균 R2의 함정에 빠지지 말고, 분산가중 R2와 그룹별 평가를 함께 봐야 합니다. 셋째이자 가장 중요한 것, 변수가 모델을 이깁니다. 물리 기반 파생변수, 특히 비선형 항을 넣는 것이 모델을 복잡하게 바꾸는 것보다 효과적이었습니다. 이 세 교훈은 ClimSim만이 아니라 거의 모든 데이터 분석에 적용됩니다.</a:t>
+            </a:r>
+            <a:endParaRPr lang="en-US" dirty="0"/>
+          </a:p>
+        </p:txBody>
+      </p:sp>
+      <p:sp>
+        <p:nvSpPr>
+          <p:cNvPr id="4" name="Slide Number Placeholder 3"/>
+          <p:cNvSpPr>
+            <a:spLocks noGrp="1"/>
+          </p:cNvSpPr>
+          <p:nvPr>
+            <p:ph type="sldNum" sz="quarter" idx="10"/>
+          </p:nvPr>
+        </p:nvSpPr>
+        <p:spPr/>
+        <p:txBody>
+          <a:bodyPr/>
+          <a:lstStyle/>
+          <a:p>
+            <a:fld id="{F7021451-1387-4CA6-816F-3879F97B5CBC}" type="slidenum">
+              <a:rPr lang="en-US"/>
+              <a:t>45</a:t>
+            </a:fld>
+            <a:endParaRPr lang="en-US"/>
+          </a:p>
+        </p:txBody>
+      </p:sp>
+    </p:spTree>
+    <p:extLst>
+      <p:ext uri="{BB962C8B-B14F-4D97-AF65-F5344CB8AC3E}">
+        <p14:creationId xmlns:p14="http://schemas.microsoft.com/office/powerpoint/2010/main" val="1024086991"/>
+      </p:ext>
+    </p:extLst>
+  </p:cSld>
+  <p:clrMapOvr>
+    <a:masterClrMapping/>
+  </p:clrMapOvr>
+</p:notes>
+</file>
+
+<file path=ppt/notesSlides/notesSlide46.xml><?xml version="1.0" encoding="utf-8"?>
+<p:notes xmlns:a="http://schemas.openxmlformats.org/drawingml/2006/main" xmlns:r="http://schemas.openxmlformats.org/officeDocument/2006/relationships" xmlns:p="http://schemas.openxmlformats.org/presentationml/2006/main">
+  <p:cSld>
+    <p:spTree>
+      <p:nvGrpSpPr>
+        <p:cNvPr id="1" name=""/>
+        <p:cNvGrpSpPr/>
+        <p:nvPr/>
+      </p:nvGrpSpPr>
+      <p:grpSpPr>
+        <a:xfrm>
+          <a:off x="0" y="0"/>
+          <a:ext cx="0" cy="0"/>
+          <a:chOff x="0" y="0"/>
+          <a:chExt cx="0" cy="0"/>
+        </a:xfrm>
+      </p:grpSpPr>
+      <p:sp>
+        <p:nvSpPr>
+          <p:cNvPr id="2" name="Slide Image Placeholder 1"/>
+          <p:cNvSpPr>
+            <a:spLocks noGrp="1" noRot="1" noChangeAspect="1"/>
+          </p:cNvSpPr>
+          <p:nvPr>
+            <p:ph type="sldImg"/>
+          </p:nvPr>
+        </p:nvSpPr>
+        <p:spPr/>
+      </p:sp>
+      <p:sp>
+        <p:nvSpPr>
+          <p:cNvPr id="3" name="Notes Placeholder 2"/>
+          <p:cNvSpPr>
+            <a:spLocks noGrp="1"/>
+          </p:cNvSpPr>
+          <p:nvPr>
+            <p:ph type="body" idx="1"/>
+          </p:nvPr>
+        </p:nvSpPr>
+        <p:spPr/>
+        <p:txBody>
+          <a:bodyPr/>
+          <a:lstStyle/>
+          <a:p>
+            <a:r>
+              <a:rPr lang="en-US" dirty="0"/>
+              <a:t>이 모든 과정은 재현 가능하도록 스크립트로 정리했습니다. download_subsampled.py로 데이터를 받고, check_data_quality.py로 품질을 점검합니다. climsim_model_comparison.py가 세 모델을 비교하고 지표로 평가하며, climsim_domain_features.py가 물리 파생변수로 개선을 시도합니다. VARIABLES.md는 변수 참고 문서입니다. 모든 스크립트는 고정 seed와 명령행 옵션을 갖추고 있어서, 누구나 같은 명령으로 같은 결과를 재현할 수 있습니다. 재현성은 좋은 데이터 분석의 기본입니다. 이걸로 오늘 파이프라인을 마칩니다.</a:t>
+            </a:r>
+            <a:endParaRPr lang="en-US" dirty="0"/>
+          </a:p>
+        </p:txBody>
+      </p:sp>
+      <p:sp>
+        <p:nvSpPr>
+          <p:cNvPr id="4" name="Slide Number Placeholder 3"/>
+          <p:cNvSpPr>
+            <a:spLocks noGrp="1"/>
+          </p:cNvSpPr>
+          <p:nvPr>
+            <p:ph type="sldNum" sz="quarter" idx="10"/>
+          </p:nvPr>
+        </p:nvSpPr>
+        <p:spPr/>
+        <p:txBody>
+          <a:bodyPr/>
+          <a:lstStyle/>
+          <a:p>
+            <a:fld id="{F7021451-1387-4CA6-816F-3879F97B5CBC}" type="slidenum">
+              <a:rPr lang="en-US"/>
+              <a:t>46</a:t>
+            </a:fld>
+            <a:endParaRPr lang="en-US"/>
+          </a:p>
+        </p:txBody>
+      </p:sp>
+    </p:spTree>
+    <p:extLst>
+      <p:ext uri="{BB962C8B-B14F-4D97-AF65-F5344CB8AC3E}">
+        <p14:creationId xmlns:p14="http://schemas.microsoft.com/office/powerpoint/2010/main" val="1024086991"/>
+      </p:ext>
+    </p:extLst>
+  </p:cSld>
+  <p:clrMapOvr>
+    <a:masterClrMapping/>
+  </p:clrMapOvr>
+</p:notes>
+</file>
+
+<file path=ppt/notesSlides/notesSlide47.xml><?xml version="1.0" encoding="utf-8"?>
+<p:notes xmlns:a="http://schemas.openxmlformats.org/drawingml/2006/main" xmlns:r="http://schemas.openxmlformats.org/officeDocument/2006/relationships" xmlns:p="http://schemas.openxmlformats.org/presentationml/2006/main">
+  <p:cSld>
+    <p:spTree>
+      <p:nvGrpSpPr>
+        <p:cNvPr id="1" name=""/>
+        <p:cNvGrpSpPr/>
+        <p:nvPr/>
+      </p:nvGrpSpPr>
+      <p:grpSpPr>
+        <a:xfrm>
+          <a:off x="0" y="0"/>
+          <a:ext cx="0" cy="0"/>
+          <a:chOff x="0" y="0"/>
+          <a:chExt cx="0" cy="0"/>
+        </a:xfrm>
+      </p:grpSpPr>
+      <p:sp>
+        <p:nvSpPr>
+          <p:cNvPr id="2" name="Slide Image Placeholder 1"/>
+          <p:cNvSpPr>
+            <a:spLocks noGrp="1" noRot="1" noChangeAspect="1"/>
+          </p:cNvSpPr>
+          <p:nvPr>
+            <p:ph type="sldImg"/>
+          </p:nvPr>
+        </p:nvSpPr>
+        <p:spPr/>
+      </p:sp>
+      <p:sp>
+        <p:nvSpPr>
+          <p:cNvPr id="3" name="Notes Placeholder 2"/>
+          <p:cNvSpPr>
+            <a:spLocks noGrp="1"/>
+          </p:cNvSpPr>
+          <p:nvPr>
+            <p:ph type="body" idx="1"/>
+          </p:nvPr>
+        </p:nvSpPr>
+        <p:spPr/>
+        <p:txBody>
+          <a:bodyPr/>
+          <a:lstStyle/>
+          <a:p>
+            <a:r>
+              <a:rPr lang="en-US" dirty="0"/>
+              <a:t>마무리하겠습니다. 오늘 우리는 데이터를 받는 것부터 품질 점검, 전처리, 모델링, 평가, 특성 공학까지 하나의 파이프라인을 따라왔습니다. 가장 큰 배움은 이것입니다. 좋은 분석은 좋은 모델에서 나오는 게 아니라, 좋은 질문과 정직한 평가에서 나온다. 데이터를 먼저 이해하고, 겉보기 지표를 의심하고, 물리 지식으로 변수를 만드는 것. 이 태도가 화려한 모델보다 결과를 더 크게 바꿨습니다. 이 관점을 가지고 데이터를 대하면, 어떤 문제에서도 숫자 너머의 진실을 볼 수 있을 것입니다. 감사합니다.</a:t>
+            </a:r>
+            <a:endParaRPr lang="en-US" dirty="0"/>
+          </a:p>
+        </p:txBody>
+      </p:sp>
+      <p:sp>
+        <p:nvSpPr>
+          <p:cNvPr id="4" name="Slide Number Placeholder 3"/>
+          <p:cNvSpPr>
+            <a:spLocks noGrp="1"/>
+          </p:cNvSpPr>
+          <p:nvPr>
+            <p:ph type="sldNum" sz="quarter" idx="10"/>
+          </p:nvPr>
+        </p:nvSpPr>
+        <p:spPr/>
+        <p:txBody>
+          <a:bodyPr/>
+          <a:lstStyle/>
+          <a:p>
+            <a:fld id="{F7021451-1387-4CA6-816F-3879F97B5CBC}" type="slidenum">
+              <a:rPr lang="en-US"/>
+              <a:t>47</a:t>
             </a:fld>
             <a:endParaRPr lang="en-US"/>
           </a:p>
@@ -17664,7 +18198,7 @@
                 <a:ea typeface="Calibri" pitchFamily="34" charset="-122"/>
                 <a:cs typeface="Calibri" pitchFamily="34" charset="-120"/>
               </a:rPr>
-              <a:t>SECTION 결론</a:t>
+              <a:t>SECTION 심화</a:t>
             </a:r>
             <a:endParaRPr lang="en-US" sz="1800" dirty="0"/>
           </a:p>
@@ -17703,7 +18237,7 @@
                 <a:ea typeface="Cambria" pitchFamily="34" charset="-122"/>
                 <a:cs typeface="Cambria" pitchFamily="34" charset="-120"/>
               </a:rPr>
-              <a:t>마무리</a:t>
+              <a:t>일반화(OOD) 검증 — 더운 기후에서도?</a:t>
             </a:r>
             <a:endParaRPr lang="en-US" sz="4400" dirty="0"/>
           </a:p>
@@ -17742,7 +18276,7 @@
                 <a:ea typeface="Calibri" pitchFamily="34" charset="-122"/>
                 <a:cs typeface="Calibri" pitchFamily="34" charset="-120"/>
               </a:rPr>
-              <a:t>핵심 교훈과 재현 가능한 파이프라인</a:t>
+              <a:t>배운 적 없는 '더 더운 기후'에서도 예측이 되는가</a:t>
             </a:r>
             <a:endParaRPr lang="en-US" sz="1800" dirty="0"/>
           </a:p>
@@ -17807,13 +18341,13 @@
             <a:r>
               <a:rPr lang="en-US" sz="1250" b="1" spc="200" kern="0" dirty="0">
                 <a:solidFill>
-                  <a:srgbClr val="1C7293"/>
+                  <a:srgbClr val="E76F51"/>
                 </a:solidFill>
                 <a:latin typeface="Calibri" pitchFamily="34" charset="0"/>
                 <a:ea typeface="Calibri" pitchFamily="34" charset="-122"/>
                 <a:cs typeface="Calibri" pitchFamily="34" charset="-120"/>
               </a:rPr>
-              <a:t>TAKEAWAYS</a:t>
+              <a:t>WHY OOD</a:t>
             </a:r>
             <a:endParaRPr lang="en-US" sz="1250" dirty="0"/>
           </a:p>
@@ -17852,7 +18386,7 @@
                 <a:ea typeface="Cambria" pitchFamily="34" charset="-122"/>
                 <a:cs typeface="Cambria" pitchFamily="34" charset="-120"/>
               </a:rPr>
-              <a:t>파이프라인이 준 세 가지 교훈</a:t>
+              <a:t>진짜 시험 — 외삽(extrapolation)</a:t>
             </a:r>
             <a:endParaRPr lang="en-US" sz="3400" dirty="0"/>
           </a:p>
@@ -17867,15 +18401,15 @@
         <p:spPr>
           <a:xfrm>
             <a:off x="640080" y="1828800"/>
-            <a:ext cx="10972800" cy="1234440"/>
+            <a:ext cx="5394960" cy="4114800"/>
           </a:xfrm>
           <a:prstGeom prst="roundRect">
             <a:avLst>
-              <a:gd name="adj" fmla="val 6667"/>
+              <a:gd name="adj" fmla="val 2000"/>
             </a:avLst>
           </a:prstGeom>
           <a:solidFill>
-            <a:srgbClr val="FFFFFF"/>
+            <a:srgbClr val="EFF4FA"/>
           </a:solidFill>
           <a:ln w="12700">
             <a:solidFill>
@@ -17894,161 +18428,115 @@
       </p:sp>
       <p:sp>
         <p:nvSpPr>
-          <p:cNvPr id="5" name="Shape 3"/>
-          <p:cNvSpPr/>
-          <p:nvPr/>
-        </p:nvSpPr>
-        <p:spPr>
-          <a:xfrm>
-            <a:off x="914400" y="2249424"/>
-            <a:ext cx="384048" cy="384048"/>
-          </a:xfrm>
-          <a:prstGeom prst="roundRect">
-            <a:avLst>
-              <a:gd name="adj" fmla="val 19048"/>
-            </a:avLst>
-          </a:prstGeom>
-          <a:solidFill>
-            <a:srgbClr val="1C4E80"/>
-          </a:solidFill>
-          <a:ln/>
-        </p:spPr>
-      </p:sp>
-      <p:sp>
-        <p:nvSpPr>
-          <p:cNvPr id="6" name="Text 4"/>
-          <p:cNvSpPr/>
-          <p:nvPr/>
-        </p:nvSpPr>
-        <p:spPr>
-          <a:xfrm>
-            <a:off x="914400" y="2249424"/>
-            <a:ext cx="384048" cy="384048"/>
-          </a:xfrm>
-          <a:prstGeom prst="rect">
-            <a:avLst/>
-          </a:prstGeom>
-          <a:noFill/>
-          <a:ln/>
-        </p:spPr>
-        <p:txBody>
-          <a:bodyPr wrap="square" rtlCol="0" anchor="ctr"/>
-          <a:lstStyle/>
-          <a:p>
-            <a:pPr algn="ctr" indent="0" marL="0">
-              <a:buNone/>
-            </a:pPr>
-            <a:r>
-              <a:rPr lang="en-US" sz="1600" b="1" dirty="0">
-                <a:solidFill>
-                  <a:srgbClr val="FFFFFF"/>
+          <p:cNvPr id="5" name="Text 3"/>
+          <p:cNvSpPr/>
+          <p:nvPr/>
+        </p:nvSpPr>
+        <p:spPr>
+          <a:xfrm>
+            <a:off x="914400" y="2148840"/>
+            <a:ext cx="4846320" cy="3657600"/>
+          </a:xfrm>
+          <a:prstGeom prst="rect">
+            <a:avLst/>
+          </a:prstGeom>
+          <a:noFill/>
+          <a:ln/>
+        </p:spPr>
+        <p:txBody>
+          <a:bodyPr wrap="square" rtlCol="0" anchor="t"/>
+          <a:lstStyle/>
+          <a:p>
+            <a:pPr indent="0" marL="0">
+              <a:spcAft>
+                <a:spcPts val="800"/>
+              </a:spcAft>
+              <a:buNone/>
+            </a:pPr>
+            <a:r>
+              <a:rPr lang="en-US" sz="1900" b="1" dirty="0">
+                <a:solidFill>
+                  <a:srgbClr val="1C4E80"/>
                 </a:solidFill>
                 <a:latin typeface="Cambria" pitchFamily="34" charset="0"/>
                 <a:ea typeface="Cambria" pitchFamily="34" charset="-122"/>
                 <a:cs typeface="Cambria" pitchFamily="34" charset="-120"/>
               </a:rPr>
-              <a:t>1</a:t>
-            </a:r>
-            <a:endParaRPr lang="en-US" sz="1600" dirty="0"/>
-          </a:p>
-        </p:txBody>
-      </p:sp>
-      <p:sp>
-        <p:nvSpPr>
-          <p:cNvPr id="7" name="Text 5"/>
-          <p:cNvSpPr/>
-          <p:nvPr/>
-        </p:nvSpPr>
-        <p:spPr>
-          <a:xfrm>
-            <a:off x="1554480" y="2011680"/>
-            <a:ext cx="9875520" cy="457200"/>
-          </a:xfrm>
-          <a:prstGeom prst="rect">
-            <a:avLst/>
-          </a:prstGeom>
-          <a:noFill/>
-          <a:ln/>
-        </p:spPr>
-        <p:txBody>
-          <a:bodyPr wrap="square" rtlCol="0" anchor="ctr"/>
-          <a:lstStyle/>
-          <a:p>
-            <a:pPr indent="0" marL="0">
-              <a:buNone/>
-            </a:pPr>
-            <a:r>
-              <a:rPr lang="en-US" sz="1900" b="1" dirty="0">
+              <a:t>IID vs OOD
+</a:t>
+            </a:r>
+            <a:endParaRPr lang="en-US" sz="1900" dirty="0"/>
+          </a:p>
+          <a:p>
+            <a:pPr indent="0" marL="0">
+              <a:spcAft>
+                <a:spcPts val="600"/>
+              </a:spcAft>
+              <a:buNone/>
+            </a:pPr>
+            <a:r>
+              <a:rPr lang="en-US" sz="1550" dirty="0">
                 <a:solidFill>
                   <a:srgbClr val="13233A"/>
                 </a:solidFill>
-                <a:latin typeface="Cambria" pitchFamily="34" charset="0"/>
-                <a:ea typeface="Cambria" pitchFamily="34" charset="-122"/>
-                <a:cs typeface="Cambria" pitchFamily="34" charset="-120"/>
-              </a:rPr>
-              <a:t>데이터를 먼저 본다</a:t>
+              </a:rPr>
+              <a:t>• 지금까지는 같은 분포에서 시험(IID)
+</a:t>
             </a:r>
             <a:endParaRPr lang="en-US" sz="1900" dirty="0"/>
           </a:p>
-        </p:txBody>
-      </p:sp>
-      <p:sp>
-        <p:nvSpPr>
-          <p:cNvPr id="8" name="Text 6"/>
-          <p:cNvSpPr/>
-          <p:nvPr/>
-        </p:nvSpPr>
-        <p:spPr>
-          <a:xfrm>
-            <a:off x="1554480" y="2487168"/>
-            <a:ext cx="9692640" cy="502920"/>
-          </a:xfrm>
-          <a:prstGeom prst="rect">
-            <a:avLst/>
-          </a:prstGeom>
-          <a:noFill/>
-          <a:ln/>
-        </p:spPr>
-        <p:txBody>
-          <a:bodyPr wrap="square" rtlCol="0" anchor="ctr"/>
-          <a:lstStyle/>
-          <a:p>
-            <a:pPr indent="0" marL="0">
-              <a:buNone/>
-            </a:pPr>
-            <a:r>
-              <a:rPr lang="en-US" sz="1450" dirty="0">
-                <a:solidFill>
-                  <a:srgbClr val="5A6B7B"/>
-                </a:solidFill>
-                <a:latin typeface="Calibri" pitchFamily="34" charset="0"/>
-                <a:ea typeface="Calibri" pitchFamily="34" charset="-122"/>
-                <a:cs typeface="Calibri" pitchFamily="34" charset="-120"/>
-              </a:rPr>
-              <a:t>품질 점검·이상치 파악이 없으면 지표를 오해한다</a:t>
-            </a:r>
-            <a:endParaRPr lang="en-US" sz="1450" dirty="0"/>
-          </a:p>
-        </p:txBody>
-      </p:sp>
-      <p:sp>
-        <p:nvSpPr>
-          <p:cNvPr id="9" name="Shape 7"/>
-          <p:cNvSpPr/>
-          <p:nvPr/>
-        </p:nvSpPr>
-        <p:spPr>
-          <a:xfrm>
-            <a:off x="640080" y="3200400"/>
-            <a:ext cx="10972800" cy="1234440"/>
+          <a:p>
+            <a:pPr indent="0" marL="0">
+              <a:spcAft>
+                <a:spcPts val="600"/>
+              </a:spcAft>
+              <a:buNone/>
+            </a:pPr>
+            <a:r>
+              <a:rPr lang="en-US" sz="1550" dirty="0">
+                <a:solidFill>
+                  <a:srgbClr val="13233A"/>
+                </a:solidFill>
+              </a:rPr>
+              <a:t>• 그러나 온난화 예측 = '본 적 없는 더운 상태' 맞히기
+</a:t>
+            </a:r>
+            <a:endParaRPr lang="en-US" sz="1900" dirty="0"/>
+          </a:p>
+          <a:p>
+            <a:pPr indent="0" marL="0">
+              <a:buNone/>
+            </a:pPr>
+            <a:r>
+              <a:rPr lang="en-US" sz="1550" dirty="0">
+                <a:solidFill>
+                  <a:srgbClr val="13233A"/>
+                </a:solidFill>
+              </a:rPr>
+              <a:t>• 모델이 데이터를 '외운' 것과 '이해한' 것을 가르는 시험</a:t>
+            </a:r>
+            <a:endParaRPr lang="en-US" sz="1900" dirty="0"/>
+          </a:p>
+        </p:txBody>
+      </p:sp>
+      <p:sp>
+        <p:nvSpPr>
+          <p:cNvPr id="6" name="Shape 4"/>
+          <p:cNvSpPr/>
+          <p:nvPr/>
+        </p:nvSpPr>
+        <p:spPr>
+          <a:xfrm>
+            <a:off x="6355080" y="1828800"/>
+            <a:ext cx="5193792" cy="4114800"/>
           </a:xfrm>
           <a:prstGeom prst="roundRect">
             <a:avLst>
-              <a:gd name="adj" fmla="val 6667"/>
+              <a:gd name="adj" fmla="val 2000"/>
             </a:avLst>
           </a:prstGeom>
           <a:solidFill>
-            <a:srgbClr val="FFFFFF"/>
+            <a:srgbClr val="FBF3EF"/>
           </a:solidFill>
           <a:ln w="12700">
             <a:solidFill>
@@ -18067,319 +18555,118 @@
       </p:sp>
       <p:sp>
         <p:nvSpPr>
-          <p:cNvPr id="10" name="Shape 8"/>
-          <p:cNvSpPr/>
-          <p:nvPr/>
-        </p:nvSpPr>
-        <p:spPr>
-          <a:xfrm>
-            <a:off x="914400" y="3621024"/>
-            <a:ext cx="384048" cy="384048"/>
-          </a:xfrm>
-          <a:prstGeom prst="roundRect">
-            <a:avLst>
-              <a:gd name="adj" fmla="val 19048"/>
-            </a:avLst>
-          </a:prstGeom>
-          <a:solidFill>
-            <a:srgbClr val="E76F51"/>
-          </a:solidFill>
-          <a:ln/>
-        </p:spPr>
-      </p:sp>
-      <p:sp>
-        <p:nvSpPr>
-          <p:cNvPr id="11" name="Text 9"/>
-          <p:cNvSpPr/>
-          <p:nvPr/>
-        </p:nvSpPr>
-        <p:spPr>
-          <a:xfrm>
-            <a:off x="914400" y="3621024"/>
-            <a:ext cx="384048" cy="384048"/>
-          </a:xfrm>
-          <a:prstGeom prst="rect">
-            <a:avLst/>
-          </a:prstGeom>
-          <a:noFill/>
-          <a:ln/>
-        </p:spPr>
-        <p:txBody>
-          <a:bodyPr wrap="square" rtlCol="0" anchor="ctr"/>
-          <a:lstStyle/>
-          <a:p>
-            <a:pPr algn="ctr" indent="0" marL="0">
-              <a:buNone/>
-            </a:pPr>
-            <a:r>
-              <a:rPr lang="en-US" sz="1600" b="1" dirty="0">
-                <a:solidFill>
-                  <a:srgbClr val="FFFFFF"/>
+          <p:cNvPr id="7" name="Text 5"/>
+          <p:cNvSpPr/>
+          <p:nvPr/>
+        </p:nvSpPr>
+        <p:spPr>
+          <a:xfrm>
+            <a:off x="6629400" y="2148840"/>
+            <a:ext cx="4663440" cy="3657600"/>
+          </a:xfrm>
+          <a:prstGeom prst="rect">
+            <a:avLst/>
+          </a:prstGeom>
+          <a:noFill/>
+          <a:ln/>
+        </p:spPr>
+        <p:txBody>
+          <a:bodyPr wrap="square" rtlCol="0" anchor="t"/>
+          <a:lstStyle/>
+          <a:p>
+            <a:pPr indent="0" marL="0">
+              <a:spcAft>
+                <a:spcPts val="800"/>
+              </a:spcAft>
+              <a:buNone/>
+            </a:pPr>
+            <a:r>
+              <a:rPr lang="en-US" sz="1900" b="1" dirty="0">
+                <a:solidFill>
+                  <a:srgbClr val="E76F51"/>
                 </a:solidFill>
                 <a:latin typeface="Cambria" pitchFamily="34" charset="0"/>
                 <a:ea typeface="Cambria" pitchFamily="34" charset="-122"/>
                 <a:cs typeface="Cambria" pitchFamily="34" charset="-120"/>
               </a:rPr>
-              <a:t>2</a:t>
-            </a:r>
-            <a:endParaRPr lang="en-US" sz="1600" dirty="0"/>
-          </a:p>
-        </p:txBody>
-      </p:sp>
-      <p:sp>
-        <p:nvSpPr>
-          <p:cNvPr id="12" name="Text 10"/>
-          <p:cNvSpPr/>
-          <p:nvPr/>
-        </p:nvSpPr>
-        <p:spPr>
-          <a:xfrm>
-            <a:off x="1554480" y="3383280"/>
-            <a:ext cx="9875520" cy="457200"/>
-          </a:xfrm>
-          <a:prstGeom prst="rect">
-            <a:avLst/>
-          </a:prstGeom>
-          <a:noFill/>
-          <a:ln/>
-        </p:spPr>
-        <p:txBody>
-          <a:bodyPr wrap="square" rtlCol="0" anchor="ctr"/>
-          <a:lstStyle/>
-          <a:p>
-            <a:pPr indent="0" marL="0">
-              <a:buNone/>
-            </a:pPr>
-            <a:r>
-              <a:rPr lang="en-US" sz="1900" b="1" dirty="0">
+              <a:t>설계
+</a:t>
+            </a:r>
+            <a:endParaRPr lang="en-US" sz="1900" dirty="0"/>
+          </a:p>
+          <a:p>
+            <a:pPr indent="0" marL="0">
+              <a:spcAft>
+                <a:spcPts val="600"/>
+              </a:spcAft>
+              <a:buNone/>
+            </a:pPr>
+            <a:r>
+              <a:rPr lang="en-US" sz="1550" dirty="0">
                 <a:solidFill>
                   <a:srgbClr val="13233A"/>
                 </a:solidFill>
-                <a:latin typeface="Cambria" pitchFamily="34" charset="0"/>
-                <a:ea typeface="Cambria" pitchFamily="34" charset="-122"/>
-                <a:cs typeface="Cambria" pitchFamily="34" charset="-120"/>
-              </a:rPr>
-              <a:t>지표를 올바로 고른다</a:t>
+              </a:rPr>
+              <a:t>① 시원한 쪽 기온으로만 학습 (평균 278K)
+</a:t>
             </a:r>
             <a:endParaRPr lang="en-US" sz="1900" dirty="0"/>
           </a:p>
-        </p:txBody>
-      </p:sp>
-      <p:sp>
-        <p:nvSpPr>
-          <p:cNvPr id="13" name="Text 11"/>
-          <p:cNvSpPr/>
-          <p:nvPr/>
-        </p:nvSpPr>
-        <p:spPr>
-          <a:xfrm>
-            <a:off x="1554480" y="3858768"/>
-            <a:ext cx="9692640" cy="502920"/>
-          </a:xfrm>
-          <a:prstGeom prst="rect">
-            <a:avLst/>
-          </a:prstGeom>
-          <a:noFill/>
-          <a:ln/>
-        </p:spPr>
-        <p:txBody>
-          <a:bodyPr wrap="square" rtlCol="0" anchor="ctr"/>
-          <a:lstStyle/>
-          <a:p>
-            <a:pPr indent="0" marL="0">
-              <a:buNone/>
-            </a:pPr>
-            <a:r>
-              <a:rPr lang="en-US" sz="1450" dirty="0">
-                <a:solidFill>
-                  <a:srgbClr val="5A6B7B"/>
-                </a:solidFill>
-                <a:latin typeface="Calibri" pitchFamily="34" charset="0"/>
-                <a:ea typeface="Calibri" pitchFamily="34" charset="-122"/>
-                <a:cs typeface="Calibri" pitchFamily="34" charset="-120"/>
-              </a:rPr>
-              <a:t>단순평균 R²의 함정 → 분산가중 R²와 그룹별 평가</a:t>
-            </a:r>
-            <a:endParaRPr lang="en-US" sz="1450" dirty="0"/>
-          </a:p>
-        </p:txBody>
-      </p:sp>
-      <p:sp>
-        <p:nvSpPr>
-          <p:cNvPr id="14" name="Shape 12"/>
-          <p:cNvSpPr/>
-          <p:nvPr/>
-        </p:nvSpPr>
-        <p:spPr>
-          <a:xfrm>
-            <a:off x="640080" y="4572000"/>
-            <a:ext cx="10972800" cy="1234440"/>
-          </a:xfrm>
-          <a:prstGeom prst="roundRect">
-            <a:avLst>
-              <a:gd name="adj" fmla="val 6667"/>
-            </a:avLst>
-          </a:prstGeom>
-          <a:solidFill>
-            <a:srgbClr val="FFFFFF"/>
-          </a:solidFill>
-          <a:ln w="12700">
-            <a:solidFill>
-              <a:srgbClr val="E2E9F1"/>
-            </a:solidFill>
-            <a:prstDash val="solid"/>
-          </a:ln>
-          <a:effectLst>
-            <a:outerShdw sx="100000" sy="100000" kx="0" ky="0" algn="bl" rotWithShape="0" blurRad="101600" dist="38100" dir="5400000">
-              <a:srgbClr val="9AAEC2">
-                <a:alpha val="40000"/>
-              </a:srgbClr>
-            </a:outerShdw>
-          </a:effectLst>
-        </p:spPr>
-      </p:sp>
-      <p:sp>
-        <p:nvSpPr>
-          <p:cNvPr id="15" name="Shape 13"/>
-          <p:cNvSpPr/>
-          <p:nvPr/>
-        </p:nvSpPr>
-        <p:spPr>
-          <a:xfrm>
-            <a:off x="914400" y="4992624"/>
-            <a:ext cx="384048" cy="384048"/>
-          </a:xfrm>
-          <a:prstGeom prst="roundRect">
-            <a:avLst>
-              <a:gd name="adj" fmla="val 19048"/>
-            </a:avLst>
-          </a:prstGeom>
-          <a:solidFill>
-            <a:srgbClr val="2A9D8F"/>
-          </a:solidFill>
-          <a:ln/>
-        </p:spPr>
-      </p:sp>
-      <p:sp>
-        <p:nvSpPr>
-          <p:cNvPr id="16" name="Text 14"/>
-          <p:cNvSpPr/>
-          <p:nvPr/>
-        </p:nvSpPr>
-        <p:spPr>
-          <a:xfrm>
-            <a:off x="914400" y="4992624"/>
-            <a:ext cx="384048" cy="384048"/>
-          </a:xfrm>
-          <a:prstGeom prst="rect">
-            <a:avLst/>
-          </a:prstGeom>
-          <a:noFill/>
-          <a:ln/>
-        </p:spPr>
-        <p:txBody>
-          <a:bodyPr wrap="square" rtlCol="0" anchor="ctr"/>
-          <a:lstStyle/>
-          <a:p>
-            <a:pPr algn="ctr" indent="0" marL="0">
-              <a:buNone/>
-            </a:pPr>
-            <a:r>
-              <a:rPr lang="en-US" sz="1600" b="1" dirty="0">
-                <a:solidFill>
-                  <a:srgbClr val="FFFFFF"/>
-                </a:solidFill>
-                <a:latin typeface="Cambria" pitchFamily="34" charset="0"/>
-                <a:ea typeface="Cambria" pitchFamily="34" charset="-122"/>
-                <a:cs typeface="Cambria" pitchFamily="34" charset="-120"/>
-              </a:rPr>
-              <a:t>3</a:t>
-            </a:r>
-            <a:endParaRPr lang="en-US" sz="1600" dirty="0"/>
-          </a:p>
-        </p:txBody>
-      </p:sp>
-      <p:sp>
-        <p:nvSpPr>
-          <p:cNvPr id="17" name="Text 15"/>
-          <p:cNvSpPr/>
-          <p:nvPr/>
-        </p:nvSpPr>
-        <p:spPr>
-          <a:xfrm>
-            <a:off x="1554480" y="4754880"/>
-            <a:ext cx="9875520" cy="457200"/>
-          </a:xfrm>
-          <a:prstGeom prst="rect">
-            <a:avLst/>
-          </a:prstGeom>
-          <a:noFill/>
-          <a:ln/>
-        </p:spPr>
-        <p:txBody>
-          <a:bodyPr wrap="square" rtlCol="0" anchor="ctr"/>
-          <a:lstStyle/>
-          <a:p>
-            <a:pPr indent="0" marL="0">
-              <a:buNone/>
-            </a:pPr>
-            <a:r>
-              <a:rPr lang="en-US" sz="1900" b="1" dirty="0">
+          <a:p>
+            <a:pPr indent="0" marL="0">
+              <a:spcAft>
+                <a:spcPts val="600"/>
+              </a:spcAft>
+              <a:buNone/>
+            </a:pPr>
+            <a:r>
+              <a:rPr lang="en-US" sz="1550" dirty="0">
                 <a:solidFill>
                   <a:srgbClr val="13233A"/>
                 </a:solidFill>
-                <a:latin typeface="Cambria" pitchFamily="34" charset="0"/>
-                <a:ea typeface="Cambria" pitchFamily="34" charset="-122"/>
-                <a:cs typeface="Cambria" pitchFamily="34" charset="-120"/>
-              </a:rPr>
-              <a:t>변수가 모델을 이긴다</a:t>
+              </a:rPr>
+              <a:t>② 더운 밴드(+17/+21/+26°)를 held-out 시험
+</a:t>
             </a:r>
             <a:endParaRPr lang="en-US" sz="1900" dirty="0"/>
           </a:p>
-        </p:txBody>
-      </p:sp>
-      <p:sp>
-        <p:nvSpPr>
-          <p:cNvPr id="18" name="Text 16"/>
-          <p:cNvSpPr/>
-          <p:nvPr/>
-        </p:nvSpPr>
-        <p:spPr>
-          <a:xfrm>
-            <a:off x="1554480" y="5230368"/>
-            <a:ext cx="9692640" cy="502920"/>
-          </a:xfrm>
-          <a:prstGeom prst="rect">
-            <a:avLst/>
-          </a:prstGeom>
-          <a:noFill/>
-          <a:ln/>
-        </p:spPr>
-        <p:txBody>
-          <a:bodyPr wrap="square" rtlCol="0" anchor="ctr"/>
-          <a:lstStyle/>
-          <a:p>
-            <a:pPr indent="0" marL="0">
-              <a:buNone/>
-            </a:pPr>
-            <a:r>
-              <a:rPr lang="en-US" sz="1450" dirty="0">
-                <a:solidFill>
-                  <a:srgbClr val="5A6B7B"/>
-                </a:solidFill>
-                <a:latin typeface="Calibri" pitchFamily="34" charset="0"/>
-                <a:ea typeface="Calibri" pitchFamily="34" charset="-122"/>
-                <a:cs typeface="Calibri" pitchFamily="34" charset="-120"/>
-              </a:rPr>
-              <a:t>물리 기반 파생변수(비선형)가 모델 교체보다 효과적</a:t>
-            </a:r>
-            <a:endParaRPr lang="en-US" sz="1450" dirty="0"/>
-          </a:p>
-        </p:txBody>
-      </p:sp>
-      <p:sp>
-        <p:nvSpPr>
-          <p:cNvPr id="19" name="Text 17"/>
+          <a:p>
+            <a:pPr indent="0" marL="0">
+              <a:spcAft>
+                <a:spcPts val="600"/>
+              </a:spcAft>
+              <a:buNone/>
+            </a:pPr>
+            <a:r>
+              <a:rPr lang="en-US" sz="1550" dirty="0">
+                <a:solidFill>
+                  <a:srgbClr val="13233A"/>
+                </a:solidFill>
+              </a:rPr>
+              <a:t>③ 지표 = 소나기(PRECC, 대류성 강수)
+</a:t>
+            </a:r>
+            <a:endParaRPr lang="en-US" sz="1900" dirty="0"/>
+          </a:p>
+          <a:p>
+            <a:pPr indent="0" marL="0">
+              <a:buNone/>
+            </a:pPr>
+            <a:r>
+              <a:rPr lang="en-US" sz="1550" b="1" dirty="0">
+                <a:solidFill>
+                  <a:srgbClr val="13233A"/>
+                </a:solidFill>
+              </a:rPr>
+              <a:t>④ 기본 입력 vs +상대습도(RH), seed 5회</a:t>
+            </a:r>
+            <a:endParaRPr lang="en-US" sz="1900" dirty="0"/>
+          </a:p>
+        </p:txBody>
+      </p:sp>
+      <p:sp>
+        <p:nvSpPr>
+          <p:cNvPr id="8" name="Text 6"/>
           <p:cNvSpPr/>
           <p:nvPr/>
         </p:nvSpPr>
@@ -18663,6 +18950,2689 @@
             <a:r>
               <a:rPr lang="en-US" sz="1250" b="1" spc="200" kern="0" dirty="0">
                 <a:solidFill>
+                  <a:srgbClr val="E76F51"/>
+                </a:solidFill>
+                <a:latin typeface="Calibri" pitchFamily="34" charset="0"/>
+                <a:ea typeface="Calibri" pitchFamily="34" charset="-122"/>
+                <a:cs typeface="Calibri" pitchFamily="34" charset="-120"/>
+              </a:rPr>
+              <a:t>DESIGN</a:t>
+            </a:r>
+            <a:endParaRPr lang="en-US" sz="1250" dirty="0"/>
+          </a:p>
+        </p:txBody>
+      </p:sp>
+      <p:sp>
+        <p:nvSpPr>
+          <p:cNvPr id="3" name="Text 1"/>
+          <p:cNvSpPr/>
+          <p:nvPr/>
+        </p:nvSpPr>
+        <p:spPr>
+          <a:xfrm>
+            <a:off x="640080" y="749808"/>
+            <a:ext cx="10972800" cy="822960"/>
+          </a:xfrm>
+          <a:prstGeom prst="rect">
+            <a:avLst/>
+          </a:prstGeom>
+          <a:noFill/>
+          <a:ln/>
+        </p:spPr>
+        <p:txBody>
+          <a:bodyPr wrap="square" rtlCol="0" anchor="ctr"/>
+          <a:lstStyle/>
+          <a:p>
+            <a:pPr indent="0" marL="0">
+              <a:buNone/>
+            </a:pPr>
+            <a:r>
+              <a:rPr lang="en-US" sz="3400" b="1" dirty="0">
+                <a:solidFill>
+                  <a:srgbClr val="13233A"/>
+                </a:solidFill>
+                <a:latin typeface="Cambria" pitchFamily="34" charset="0"/>
+                <a:ea typeface="Cambria" pitchFamily="34" charset="-122"/>
+                <a:cs typeface="Cambria" pitchFamily="34" charset="-120"/>
+              </a:rPr>
+              <a:t>실험 설계 — 시원한 쪽으로 학습, 더운 쪽 시험</a:t>
+            </a:r>
+            <a:endParaRPr lang="en-US" sz="3400" dirty="0"/>
+          </a:p>
+        </p:txBody>
+      </p:sp>
+      <p:pic>
+        <p:nvPicPr>
+          <p:cNvPr id="4" name="Image 0" descr="img2/ood_design.png">    </p:cNvPr>
+          <p:cNvPicPr>
+            <a:picLocks noChangeAspect="1"/>
+          </p:cNvPicPr>
+          <p:nvPr/>
+        </p:nvPicPr>
+        <p:blipFill>
+          <a:blip r:embed="rId1"/>
+          <a:stretch>
+            <a:fillRect/>
+          </a:stretch>
+        </p:blipFill>
+        <p:spPr>
+          <a:xfrm>
+            <a:off x="502920" y="2011680"/>
+            <a:ext cx="11155680" cy="2971800"/>
+          </a:xfrm>
+          <a:prstGeom prst="rect">
+            <a:avLst/>
+          </a:prstGeom>
+        </p:spPr>
+      </p:pic>
+      <p:sp>
+        <p:nvSpPr>
+          <p:cNvPr id="5" name="Text 2"/>
+          <p:cNvSpPr/>
+          <p:nvPr/>
+        </p:nvSpPr>
+        <p:spPr>
+          <a:xfrm>
+            <a:off x="640080" y="5212080"/>
+            <a:ext cx="10972800" cy="457200"/>
+          </a:xfrm>
+          <a:prstGeom prst="rect">
+            <a:avLst/>
+          </a:prstGeom>
+          <a:noFill/>
+          <a:ln/>
+        </p:spPr>
+        <p:txBody>
+          <a:bodyPr wrap="square" rtlCol="0" anchor="ctr"/>
+          <a:lstStyle/>
+          <a:p>
+            <a:pPr algn="ctr" indent="0" marL="0">
+              <a:buNone/>
+            </a:pPr>
+            <a:r>
+              <a:rPr lang="en-US" sz="1500" i="1" dirty="0">
+                <a:solidFill>
+                  <a:srgbClr val="5A6B7B"/>
+                </a:solidFill>
+                <a:latin typeface="Calibri" pitchFamily="34" charset="0"/>
+                <a:ea typeface="Calibri" pitchFamily="34" charset="-122"/>
+                <a:cs typeface="Calibri" pitchFamily="34" charset="-120"/>
+              </a:rPr>
+              <a:t>지표기온 기준으로 시원한 절반만 학습 → 더 더운 구간을 단계별로 빼놓고 시험(외삽 스트레스 테스트).</a:t>
+            </a:r>
+            <a:endParaRPr lang="en-US" sz="1500" dirty="0"/>
+          </a:p>
+        </p:txBody>
+      </p:sp>
+      <p:sp>
+        <p:nvSpPr>
+          <p:cNvPr id="6" name="Text 3"/>
+          <p:cNvSpPr/>
+          <p:nvPr/>
+        </p:nvSpPr>
+        <p:spPr>
+          <a:xfrm>
+            <a:off x="11430000" y="6419088"/>
+            <a:ext cx="548640" cy="320040"/>
+          </a:xfrm>
+          <a:prstGeom prst="rect">
+            <a:avLst/>
+          </a:prstGeom>
+          <a:noFill/>
+          <a:ln/>
+        </p:spPr>
+        <p:txBody>
+          <a:bodyPr wrap="square" rtlCol="0" anchor="ctr"/>
+          <a:lstStyle/>
+          <a:p>
+            <a:pPr algn="r" indent="0" marL="0">
+              <a:buNone/>
+            </a:pPr>
+            <a:r>
+              <a:rPr lang="en-US" sz="1100" dirty="0">
+                <a:solidFill>
+                  <a:srgbClr val="5A6B7B"/>
+                </a:solidFill>
+                <a:latin typeface="Calibri" pitchFamily="34" charset="0"/>
+                <a:ea typeface="Calibri" pitchFamily="34" charset="-122"/>
+                <a:cs typeface="Calibri" pitchFamily="34" charset="-120"/>
+              </a:rPr>
+              <a:t>40</a:t>
+            </a:r>
+            <a:endParaRPr lang="en-US" sz="1100" dirty="0"/>
+          </a:p>
+        </p:txBody>
+      </p:sp>
+    </p:spTree>
+  </p:cSld>
+  <p:clrMapOvr>
+    <a:masterClrMapping/>
+  </p:clrMapOvr>
+</p:sld>
+</file>
+
+<file path=ppt/slides/slide41.xml><?xml version="1.0" encoding="utf-8"?>
+<p:sld xmlns:a="http://schemas.openxmlformats.org/drawingml/2006/main" xmlns:r="http://schemas.openxmlformats.org/officeDocument/2006/relationships" xmlns:p="http://schemas.openxmlformats.org/presentationml/2006/main">
+  <p:cSld name="Slide 41">
+    <p:bg>
+      <p:bgPr>
+        <a:solidFill>
+          <a:srgbClr val="F4F7FB"/>
+        </a:solidFill>
+      </p:bgPr>
+    </p:bg>
+    <p:spTree>
+      <p:nvGrpSpPr>
+        <p:cNvPr id="1" name=""/>
+        <p:cNvGrpSpPr/>
+        <p:nvPr/>
+      </p:nvGrpSpPr>
+      <p:grpSpPr>
+        <a:xfrm>
+          <a:off x="0" y="0"/>
+          <a:ext cx="0" cy="0"/>
+          <a:chOff x="0" y="0"/>
+          <a:chExt cx="0" cy="0"/>
+        </a:xfrm>
+      </p:grpSpPr>
+      <p:sp>
+        <p:nvSpPr>
+          <p:cNvPr id="2" name="Text 0"/>
+          <p:cNvSpPr/>
+          <p:nvPr/>
+        </p:nvSpPr>
+        <p:spPr>
+          <a:xfrm>
+            <a:off x="640080" y="457200"/>
+            <a:ext cx="8229600" cy="320040"/>
+          </a:xfrm>
+          <a:prstGeom prst="rect">
+            <a:avLst/>
+          </a:prstGeom>
+          <a:noFill/>
+          <a:ln/>
+        </p:spPr>
+        <p:txBody>
+          <a:bodyPr wrap="square" rtlCol="0" anchor="ctr"/>
+          <a:lstStyle/>
+          <a:p>
+            <a:pPr indent="0" marL="0">
+              <a:buNone/>
+            </a:pPr>
+            <a:r>
+              <a:rPr lang="en-US" sz="1250" b="1" spc="200" kern="0" dirty="0">
+                <a:solidFill>
+                  <a:srgbClr val="E76F51"/>
+                </a:solidFill>
+                <a:latin typeface="Calibri" pitchFamily="34" charset="0"/>
+                <a:ea typeface="Calibri" pitchFamily="34" charset="-122"/>
+                <a:cs typeface="Calibri" pitchFamily="34" charset="-120"/>
+              </a:rPr>
+              <a:t>RESULT · OOD</a:t>
+            </a:r>
+            <a:endParaRPr lang="en-US" sz="1250" dirty="0"/>
+          </a:p>
+        </p:txBody>
+      </p:sp>
+      <p:sp>
+        <p:nvSpPr>
+          <p:cNvPr id="3" name="Text 1"/>
+          <p:cNvSpPr/>
+          <p:nvPr/>
+        </p:nvSpPr>
+        <p:spPr>
+          <a:xfrm>
+            <a:off x="640080" y="749808"/>
+            <a:ext cx="10972800" cy="822960"/>
+          </a:xfrm>
+          <a:prstGeom prst="rect">
+            <a:avLst/>
+          </a:prstGeom>
+          <a:noFill/>
+          <a:ln/>
+        </p:spPr>
+        <p:txBody>
+          <a:bodyPr wrap="square" rtlCol="0" anchor="ctr"/>
+          <a:lstStyle/>
+          <a:p>
+            <a:pPr indent="0" marL="0">
+              <a:buNone/>
+            </a:pPr>
+            <a:r>
+              <a:rPr lang="en-US" sz="3400" b="1" dirty="0">
+                <a:solidFill>
+                  <a:srgbClr val="13233A"/>
+                </a:solidFill>
+                <a:latin typeface="Cambria" pitchFamily="34" charset="0"/>
+                <a:ea typeface="Cambria" pitchFamily="34" charset="-122"/>
+                <a:cs typeface="Cambria" pitchFamily="34" charset="-120"/>
+              </a:rPr>
+              <a:t>결과 ⑤ 더운 기후에서 RH가 예측을 살린다</a:t>
+            </a:r>
+            <a:endParaRPr lang="en-US" sz="3400" dirty="0"/>
+          </a:p>
+        </p:txBody>
+      </p:sp>
+      <p:pic>
+        <p:nvPicPr>
+          <p:cNvPr id="4" name="Image 0" descr="img2/ood_line.png">    </p:cNvPr>
+          <p:cNvPicPr>
+            <a:picLocks noChangeAspect="1"/>
+          </p:cNvPicPr>
+          <p:nvPr/>
+        </p:nvPicPr>
+        <p:blipFill>
+          <a:blip r:embed="rId1"/>
+          <a:stretch>
+            <a:fillRect/>
+          </a:stretch>
+        </p:blipFill>
+        <p:spPr>
+          <a:xfrm>
+            <a:off x="502920" y="1783080"/>
+            <a:ext cx="7452360" cy="4114800"/>
+          </a:xfrm>
+          <a:prstGeom prst="rect">
+            <a:avLst/>
+          </a:prstGeom>
+        </p:spPr>
+      </p:pic>
+      <p:sp>
+        <p:nvSpPr>
+          <p:cNvPr id="5" name="Shape 2"/>
+          <p:cNvSpPr/>
+          <p:nvPr/>
+        </p:nvSpPr>
+        <p:spPr>
+          <a:xfrm>
+            <a:off x="8092440" y="1828800"/>
+            <a:ext cx="3474720" cy="4069080"/>
+          </a:xfrm>
+          <a:prstGeom prst="roundRect">
+            <a:avLst>
+              <a:gd name="adj" fmla="val 2368"/>
+            </a:avLst>
+          </a:prstGeom>
+          <a:solidFill>
+            <a:srgbClr val="FBECEA"/>
+          </a:solidFill>
+          <a:ln w="12700">
+            <a:solidFill>
+              <a:srgbClr val="E2E9F1"/>
+            </a:solidFill>
+            <a:prstDash val="solid"/>
+          </a:ln>
+          <a:effectLst>
+            <a:outerShdw sx="100000" sy="100000" kx="0" ky="0" algn="bl" rotWithShape="0" blurRad="101600" dist="38100" dir="5400000">
+              <a:srgbClr val="9AAEC2">
+                <a:alpha val="40000"/>
+              </a:srgbClr>
+            </a:outerShdw>
+          </a:effectLst>
+        </p:spPr>
+      </p:sp>
+      <p:sp>
+        <p:nvSpPr>
+          <p:cNvPr id="6" name="Text 3"/>
+          <p:cNvSpPr/>
+          <p:nvPr/>
+        </p:nvSpPr>
+        <p:spPr>
+          <a:xfrm>
+            <a:off x="8321040" y="2148840"/>
+            <a:ext cx="3017520" cy="3566160"/>
+          </a:xfrm>
+          <a:prstGeom prst="rect">
+            <a:avLst/>
+          </a:prstGeom>
+          <a:noFill/>
+          <a:ln/>
+        </p:spPr>
+        <p:txBody>
+          <a:bodyPr wrap="square" rtlCol="0" anchor="t"/>
+          <a:lstStyle/>
+          <a:p>
+            <a:pPr indent="0" marL="0">
+              <a:spcAft>
+                <a:spcPts val="800"/>
+              </a:spcAft>
+              <a:buNone/>
+            </a:pPr>
+            <a:r>
+              <a:rPr lang="en-US" sz="1700" b="1" dirty="0">
+                <a:solidFill>
+                  <a:srgbClr val="E76F51"/>
+                </a:solidFill>
+                <a:latin typeface="Cambria" pitchFamily="34" charset="0"/>
+                <a:ea typeface="Cambria" pitchFamily="34" charset="-122"/>
+                <a:cs typeface="Cambria" pitchFamily="34" charset="-120"/>
+              </a:rPr>
+              <a:t>가장 더운 밴드
+</a:t>
+            </a:r>
+            <a:endParaRPr lang="en-US" sz="1700" dirty="0"/>
+          </a:p>
+          <a:p>
+            <a:pPr indent="0" marL="0">
+              <a:buNone/>
+            </a:pPr>
+            <a:r>
+              <a:rPr lang="en-US" sz="1400" dirty="0">
+                <a:solidFill>
+                  <a:srgbClr val="5A6B7B"/>
+                </a:solidFill>
+              </a:rPr>
+              <a:t>기본 입력
+</a:t>
+            </a:r>
+            <a:endParaRPr lang="en-US" sz="1700" dirty="0"/>
+          </a:p>
+          <a:p>
+            <a:pPr indent="0" marL="0">
+              <a:buNone/>
+            </a:pPr>
+            <a:r>
+              <a:rPr lang="en-US" sz="1700" b="1" dirty="0">
+                <a:solidFill>
+                  <a:srgbClr val="D9534F"/>
+                </a:solidFill>
+                <a:latin typeface="Consolas" pitchFamily="34" charset="0"/>
+                <a:ea typeface="Consolas" pitchFamily="34" charset="-122"/>
+                <a:cs typeface="Consolas" pitchFamily="34" charset="-120"/>
+              </a:rPr>
+              <a:t>−0.12 ± 0.13
+(붕괴·불안정)
+</a:t>
+            </a:r>
+            <a:endParaRPr lang="en-US" sz="1700" dirty="0"/>
+          </a:p>
+          <a:p>
+            <a:pPr indent="0" marL="0">
+              <a:buNone/>
+            </a:pPr>
+            <a:r>
+              <a:rPr lang="en-US" sz="1400" dirty="0">
+                <a:solidFill>
+                  <a:srgbClr val="5A6B7B"/>
+                </a:solidFill>
+              </a:rPr>
+              <a:t>+ 상대습도
+</a:t>
+            </a:r>
+            <a:endParaRPr lang="en-US" sz="1700" dirty="0"/>
+          </a:p>
+          <a:p>
+            <a:pPr indent="0" marL="0">
+              <a:buNone/>
+            </a:pPr>
+            <a:r>
+              <a:rPr lang="en-US" sz="1700" b="1" dirty="0">
+                <a:solidFill>
+                  <a:srgbClr val="2E8B6F"/>
+                </a:solidFill>
+                <a:latin typeface="Consolas" pitchFamily="34" charset="0"/>
+                <a:ea typeface="Consolas" pitchFamily="34" charset="-122"/>
+                <a:cs typeface="Consolas" pitchFamily="34" charset="-120"/>
+              </a:rPr>
+              <a:t>+0.21 ± 0.07
+(생존·안정)
+</a:t>
+            </a:r>
+            <a:endParaRPr lang="en-US" sz="1700" dirty="0"/>
+          </a:p>
+          <a:p>
+            <a:pPr indent="0" marL="0">
+              <a:buNone/>
+            </a:pPr>
+            <a:r>
+              <a:rPr lang="en-US" sz="1300" dirty="0">
+                <a:solidFill>
+                  <a:srgbClr val="13233A"/>
+                </a:solidFill>
+              </a:rPr>
+              <a:t>CI가 겹치지 않음 → 통계적으로 뚜렷한 차이</a:t>
+            </a:r>
+            <a:endParaRPr lang="en-US" sz="1700" dirty="0"/>
+          </a:p>
+        </p:txBody>
+      </p:sp>
+      <p:sp>
+        <p:nvSpPr>
+          <p:cNvPr id="7" name="Text 4"/>
+          <p:cNvSpPr/>
+          <p:nvPr/>
+        </p:nvSpPr>
+        <p:spPr>
+          <a:xfrm>
+            <a:off x="11430000" y="6419088"/>
+            <a:ext cx="548640" cy="320040"/>
+          </a:xfrm>
+          <a:prstGeom prst="rect">
+            <a:avLst/>
+          </a:prstGeom>
+          <a:noFill/>
+          <a:ln/>
+        </p:spPr>
+        <p:txBody>
+          <a:bodyPr wrap="square" rtlCol="0" anchor="ctr"/>
+          <a:lstStyle/>
+          <a:p>
+            <a:pPr algn="r" indent="0" marL="0">
+              <a:buNone/>
+            </a:pPr>
+            <a:r>
+              <a:rPr lang="en-US" sz="1100" dirty="0">
+                <a:solidFill>
+                  <a:srgbClr val="5A6B7B"/>
+                </a:solidFill>
+                <a:latin typeface="Calibri" pitchFamily="34" charset="0"/>
+                <a:ea typeface="Calibri" pitchFamily="34" charset="-122"/>
+                <a:cs typeface="Calibri" pitchFamily="34" charset="-120"/>
+              </a:rPr>
+              <a:t>41</a:t>
+            </a:r>
+            <a:endParaRPr lang="en-US" sz="1100" dirty="0"/>
+          </a:p>
+        </p:txBody>
+      </p:sp>
+    </p:spTree>
+  </p:cSld>
+  <p:clrMapOvr>
+    <a:masterClrMapping/>
+  </p:clrMapOvr>
+</p:sld>
+</file>
+
+<file path=ppt/slides/slide42.xml><?xml version="1.0" encoding="utf-8"?>
+<p:sld xmlns:a="http://schemas.openxmlformats.org/drawingml/2006/main" xmlns:r="http://schemas.openxmlformats.org/officeDocument/2006/relationships" xmlns:p="http://schemas.openxmlformats.org/presentationml/2006/main">
+  <p:cSld name="Slide 42">
+    <p:bg>
+      <p:bgPr>
+        <a:solidFill>
+          <a:srgbClr val="F4F7FB"/>
+        </a:solidFill>
+      </p:bgPr>
+    </p:bg>
+    <p:spTree>
+      <p:nvGrpSpPr>
+        <p:cNvPr id="1" name=""/>
+        <p:cNvGrpSpPr/>
+        <p:nvPr/>
+      </p:nvGrpSpPr>
+      <p:grpSpPr>
+        <a:xfrm>
+          <a:off x="0" y="0"/>
+          <a:ext cx="0" cy="0"/>
+          <a:chOff x="0" y="0"/>
+          <a:chExt cx="0" cy="0"/>
+        </a:xfrm>
+      </p:grpSpPr>
+      <p:sp>
+        <p:nvSpPr>
+          <p:cNvPr id="2" name="Text 0"/>
+          <p:cNvSpPr/>
+          <p:nvPr/>
+        </p:nvSpPr>
+        <p:spPr>
+          <a:xfrm>
+            <a:off x="640080" y="457200"/>
+            <a:ext cx="8229600" cy="320040"/>
+          </a:xfrm>
+          <a:prstGeom prst="rect">
+            <a:avLst/>
+          </a:prstGeom>
+          <a:noFill/>
+          <a:ln/>
+        </p:spPr>
+        <p:txBody>
+          <a:bodyPr wrap="square" rtlCol="0" anchor="ctr"/>
+          <a:lstStyle/>
+          <a:p>
+            <a:pPr indent="0" marL="0">
+              <a:buNone/>
+            </a:pPr>
+            <a:r>
+              <a:rPr lang="en-US" sz="1250" b="1" spc="200" kern="0" dirty="0">
+                <a:solidFill>
+                  <a:srgbClr val="E76F51"/>
+                </a:solidFill>
+                <a:latin typeface="Calibri" pitchFamily="34" charset="0"/>
+                <a:ea typeface="Calibri" pitchFamily="34" charset="-122"/>
+                <a:cs typeface="Calibri" pitchFamily="34" charset="-120"/>
+              </a:rPr>
+              <a:t>STABILITY</a:t>
+            </a:r>
+            <a:endParaRPr lang="en-US" sz="1250" dirty="0"/>
+          </a:p>
+        </p:txBody>
+      </p:sp>
+      <p:sp>
+        <p:nvSpPr>
+          <p:cNvPr id="3" name="Text 1"/>
+          <p:cNvSpPr/>
+          <p:nvPr/>
+        </p:nvSpPr>
+        <p:spPr>
+          <a:xfrm>
+            <a:off x="640080" y="749808"/>
+            <a:ext cx="10972800" cy="822960"/>
+          </a:xfrm>
+          <a:prstGeom prst="rect">
+            <a:avLst/>
+          </a:prstGeom>
+          <a:noFill/>
+          <a:ln/>
+        </p:spPr>
+        <p:txBody>
+          <a:bodyPr wrap="square" rtlCol="0" anchor="ctr"/>
+          <a:lstStyle/>
+          <a:p>
+            <a:pPr indent="0" marL="0">
+              <a:buNone/>
+            </a:pPr>
+            <a:r>
+              <a:rPr lang="en-US" sz="3400" b="1" dirty="0">
+                <a:solidFill>
+                  <a:srgbClr val="13233A"/>
+                </a:solidFill>
+                <a:latin typeface="Cambria" pitchFamily="34" charset="0"/>
+                <a:ea typeface="Cambria" pitchFamily="34" charset="-122"/>
+                <a:cs typeface="Cambria" pitchFamily="34" charset="-120"/>
+              </a:rPr>
+              <a:t>우연이 아니다 — 반복 실험의 안정성</a:t>
+            </a:r>
+            <a:endParaRPr lang="en-US" sz="3400" dirty="0"/>
+          </a:p>
+        </p:txBody>
+      </p:sp>
+      <p:pic>
+        <p:nvPicPr>
+          <p:cNvPr id="4" name="Image 0" descr="img2/ood_seeds.png">    </p:cNvPr>
+          <p:cNvPicPr>
+            <a:picLocks noChangeAspect="1"/>
+          </p:cNvPicPr>
+          <p:nvPr/>
+        </p:nvPicPr>
+        <p:blipFill>
+          <a:blip r:embed="rId1"/>
+          <a:stretch>
+            <a:fillRect/>
+          </a:stretch>
+        </p:blipFill>
+        <p:spPr>
+          <a:xfrm>
+            <a:off x="502920" y="1737360"/>
+            <a:ext cx="6858000" cy="3291840"/>
+          </a:xfrm>
+          <a:prstGeom prst="rect">
+            <a:avLst/>
+          </a:prstGeom>
+        </p:spPr>
+      </p:pic>
+      <p:sp>
+        <p:nvSpPr>
+          <p:cNvPr id="5" name="Shape 2"/>
+          <p:cNvSpPr/>
+          <p:nvPr/>
+        </p:nvSpPr>
+        <p:spPr>
+          <a:xfrm>
+            <a:off x="7498080" y="1783080"/>
+            <a:ext cx="4069080" cy="3200400"/>
+          </a:xfrm>
+          <a:prstGeom prst="roundRect">
+            <a:avLst>
+              <a:gd name="adj" fmla="val 2571"/>
+            </a:avLst>
+          </a:prstGeom>
+          <a:solidFill>
+            <a:srgbClr val="EFF4FA"/>
+          </a:solidFill>
+          <a:ln w="12700">
+            <a:solidFill>
+              <a:srgbClr val="E2E9F1"/>
+            </a:solidFill>
+            <a:prstDash val="solid"/>
+          </a:ln>
+          <a:effectLst>
+            <a:outerShdw sx="100000" sy="100000" kx="0" ky="0" algn="bl" rotWithShape="0" blurRad="101600" dist="38100" dir="5400000">
+              <a:srgbClr val="9AAEC2">
+                <a:alpha val="40000"/>
+              </a:srgbClr>
+            </a:outerShdw>
+          </a:effectLst>
+        </p:spPr>
+      </p:sp>
+      <p:sp>
+        <p:nvSpPr>
+          <p:cNvPr id="6" name="Text 3"/>
+          <p:cNvSpPr/>
+          <p:nvPr/>
+        </p:nvSpPr>
+        <p:spPr>
+          <a:xfrm>
+            <a:off x="7726680" y="2057400"/>
+            <a:ext cx="3611880" cy="2743200"/>
+          </a:xfrm>
+          <a:prstGeom prst="rect">
+            <a:avLst/>
+          </a:prstGeom>
+          <a:noFill/>
+          <a:ln/>
+        </p:spPr>
+        <p:txBody>
+          <a:bodyPr wrap="square" rtlCol="0" anchor="t"/>
+          <a:lstStyle/>
+          <a:p>
+            <a:pPr indent="0" marL="0">
+              <a:spcAft>
+                <a:spcPts val="800"/>
+              </a:spcAft>
+              <a:buNone/>
+            </a:pPr>
+            <a:r>
+              <a:rPr lang="en-US" sz="1500" b="1" dirty="0">
+                <a:solidFill>
+                  <a:srgbClr val="1C4E80"/>
+                </a:solidFill>
+                <a:latin typeface="Cambria" pitchFamily="34" charset="0"/>
+                <a:ea typeface="Cambria" pitchFamily="34" charset="-122"/>
+                <a:cs typeface="Cambria" pitchFamily="34" charset="-120"/>
+              </a:rPr>
+              <a:t>가장 더운 밴드, seed 5개
+</a:t>
+            </a:r>
+            <a:endParaRPr lang="en-US" sz="1500" dirty="0"/>
+          </a:p>
+          <a:p>
+            <a:pPr indent="0" marL="0">
+              <a:buNone/>
+            </a:pPr>
+            <a:r>
+              <a:rPr lang="en-US" sz="1350" dirty="0">
+                <a:solidFill>
+                  <a:srgbClr val="13233A"/>
+                </a:solidFill>
+              </a:rPr>
+              <a:t>기본: 0.02, −0.09, −0.35, −0.03, −0.16
+→ 0을 넘나듦(불안정)
+</a:t>
+            </a:r>
+            <a:endParaRPr lang="en-US" sz="1500" dirty="0"/>
+          </a:p>
+          <a:p>
+            <a:pPr indent="0" marL="0">
+              <a:buNone/>
+            </a:pPr>
+            <a:r>
+              <a:rPr lang="en-US" sz="1350" b="1" dirty="0">
+                <a:solidFill>
+                  <a:srgbClr val="13233A"/>
+                </a:solidFill>
+              </a:rPr>
+              <a:t>+RH: 0.23, 0.25, 0.15, 0.31, 0.13</a:t>
+            </a:r>
+            <a:endParaRPr lang="en-US" sz="1500" dirty="0"/>
+          </a:p>
+          <a:p>
+            <a:pPr indent="0" marL="0">
+              <a:buNone/>
+            </a:pPr>
+            <a:r>
+              <a:rPr lang="en-US" sz="1350" b="1" dirty="0">
+                <a:solidFill>
+                  <a:srgbClr val="13233A"/>
+                </a:solidFill>
+              </a:rPr>
+              <a:t>→ 모두 양수(안정)</a:t>
+            </a:r>
+            <a:endParaRPr lang="en-US" sz="1500" dirty="0"/>
+          </a:p>
+        </p:txBody>
+      </p:sp>
+      <p:sp>
+        <p:nvSpPr>
+          <p:cNvPr id="7" name="Text 4"/>
+          <p:cNvSpPr/>
+          <p:nvPr/>
+        </p:nvSpPr>
+        <p:spPr>
+          <a:xfrm>
+            <a:off x="640080" y="5257800"/>
+            <a:ext cx="1554480" cy="365760"/>
+          </a:xfrm>
+          <a:prstGeom prst="rect">
+            <a:avLst/>
+          </a:prstGeom>
+          <a:noFill/>
+          <a:ln/>
+        </p:spPr>
+        <p:txBody>
+          <a:bodyPr wrap="square" rtlCol="0" anchor="ctr"/>
+          <a:lstStyle/>
+          <a:p>
+            <a:pPr algn="l" indent="0" marL="0">
+              <a:buNone/>
+            </a:pPr>
+            <a:endParaRPr lang="en-US" sz="1300" dirty="0"/>
+          </a:p>
+        </p:txBody>
+      </p:sp>
+      <p:sp>
+        <p:nvSpPr>
+          <p:cNvPr id="8" name="Text 5"/>
+          <p:cNvSpPr/>
+          <p:nvPr/>
+        </p:nvSpPr>
+        <p:spPr>
+          <a:xfrm>
+            <a:off x="2194560" y="5257800"/>
+            <a:ext cx="2240280" cy="365760"/>
+          </a:xfrm>
+          <a:prstGeom prst="rect">
+            <a:avLst/>
+          </a:prstGeom>
+          <a:noFill/>
+          <a:ln/>
+        </p:spPr>
+        <p:txBody>
+          <a:bodyPr wrap="square" rtlCol="0" anchor="ctr"/>
+          <a:lstStyle/>
+          <a:p>
+            <a:pPr algn="ctr" indent="0" marL="0">
+              <a:buNone/>
+            </a:pPr>
+            <a:r>
+              <a:rPr lang="en-US" sz="1300" b="1" dirty="0">
+                <a:solidFill>
+                  <a:srgbClr val="5A6B7B"/>
+                </a:solidFill>
+                <a:latin typeface="Calibri" pitchFamily="34" charset="0"/>
+                <a:ea typeface="Calibri" pitchFamily="34" charset="-122"/>
+                <a:cs typeface="Calibri" pitchFamily="34" charset="-120"/>
+              </a:rPr>
+              <a:t>같은날씨</a:t>
+            </a:r>
+            <a:endParaRPr lang="en-US" sz="1300" dirty="0"/>
+          </a:p>
+        </p:txBody>
+      </p:sp>
+      <p:sp>
+        <p:nvSpPr>
+          <p:cNvPr id="9" name="Text 6"/>
+          <p:cNvSpPr/>
+          <p:nvPr/>
+        </p:nvSpPr>
+        <p:spPr>
+          <a:xfrm>
+            <a:off x="4434840" y="5257800"/>
+            <a:ext cx="2240280" cy="365760"/>
+          </a:xfrm>
+          <a:prstGeom prst="rect">
+            <a:avLst/>
+          </a:prstGeom>
+          <a:noFill/>
+          <a:ln/>
+        </p:spPr>
+        <p:txBody>
+          <a:bodyPr wrap="square" rtlCol="0" anchor="ctr"/>
+          <a:lstStyle/>
+          <a:p>
+            <a:pPr algn="ctr" indent="0" marL="0">
+              <a:buNone/>
+            </a:pPr>
+            <a:r>
+              <a:rPr lang="en-US" sz="1300" b="1" dirty="0">
+                <a:solidFill>
+                  <a:srgbClr val="5A6B7B"/>
+                </a:solidFill>
+                <a:latin typeface="Calibri" pitchFamily="34" charset="0"/>
+                <a:ea typeface="Calibri" pitchFamily="34" charset="-122"/>
+                <a:cs typeface="Calibri" pitchFamily="34" charset="-120"/>
+              </a:rPr>
+              <a:t>+17°</a:t>
+            </a:r>
+            <a:endParaRPr lang="en-US" sz="1300" dirty="0"/>
+          </a:p>
+        </p:txBody>
+      </p:sp>
+      <p:sp>
+        <p:nvSpPr>
+          <p:cNvPr id="10" name="Text 7"/>
+          <p:cNvSpPr/>
+          <p:nvPr/>
+        </p:nvSpPr>
+        <p:spPr>
+          <a:xfrm>
+            <a:off x="6675120" y="5257800"/>
+            <a:ext cx="2240280" cy="365760"/>
+          </a:xfrm>
+          <a:prstGeom prst="rect">
+            <a:avLst/>
+          </a:prstGeom>
+          <a:noFill/>
+          <a:ln/>
+        </p:spPr>
+        <p:txBody>
+          <a:bodyPr wrap="square" rtlCol="0" anchor="ctr"/>
+          <a:lstStyle/>
+          <a:p>
+            <a:pPr algn="ctr" indent="0" marL="0">
+              <a:buNone/>
+            </a:pPr>
+            <a:r>
+              <a:rPr lang="en-US" sz="1300" b="1" dirty="0">
+                <a:solidFill>
+                  <a:srgbClr val="5A6B7B"/>
+                </a:solidFill>
+                <a:latin typeface="Calibri" pitchFamily="34" charset="0"/>
+                <a:ea typeface="Calibri" pitchFamily="34" charset="-122"/>
+                <a:cs typeface="Calibri" pitchFamily="34" charset="-120"/>
+              </a:rPr>
+              <a:t>+21°</a:t>
+            </a:r>
+            <a:endParaRPr lang="en-US" sz="1300" dirty="0"/>
+          </a:p>
+        </p:txBody>
+      </p:sp>
+      <p:sp>
+        <p:nvSpPr>
+          <p:cNvPr id="11" name="Text 8"/>
+          <p:cNvSpPr/>
+          <p:nvPr/>
+        </p:nvSpPr>
+        <p:spPr>
+          <a:xfrm>
+            <a:off x="8915400" y="5257800"/>
+            <a:ext cx="2240280" cy="365760"/>
+          </a:xfrm>
+          <a:prstGeom prst="rect">
+            <a:avLst/>
+          </a:prstGeom>
+          <a:noFill/>
+          <a:ln/>
+        </p:spPr>
+        <p:txBody>
+          <a:bodyPr wrap="square" rtlCol="0" anchor="ctr"/>
+          <a:lstStyle/>
+          <a:p>
+            <a:pPr algn="ctr" indent="0" marL="0">
+              <a:buNone/>
+            </a:pPr>
+            <a:r>
+              <a:rPr lang="en-US" sz="1300" b="1" dirty="0">
+                <a:solidFill>
+                  <a:srgbClr val="5A6B7B"/>
+                </a:solidFill>
+                <a:latin typeface="Calibri" pitchFamily="34" charset="0"/>
+                <a:ea typeface="Calibri" pitchFamily="34" charset="-122"/>
+                <a:cs typeface="Calibri" pitchFamily="34" charset="-120"/>
+              </a:rPr>
+              <a:t>+26°</a:t>
+            </a:r>
+            <a:endParaRPr lang="en-US" sz="1300" dirty="0"/>
+          </a:p>
+        </p:txBody>
+      </p:sp>
+      <p:sp>
+        <p:nvSpPr>
+          <p:cNvPr id="12" name="Text 9"/>
+          <p:cNvSpPr/>
+          <p:nvPr/>
+        </p:nvSpPr>
+        <p:spPr>
+          <a:xfrm>
+            <a:off x="640080" y="5641848"/>
+            <a:ext cx="1554480" cy="365760"/>
+          </a:xfrm>
+          <a:prstGeom prst="rect">
+            <a:avLst/>
+          </a:prstGeom>
+          <a:noFill/>
+          <a:ln/>
+        </p:spPr>
+        <p:txBody>
+          <a:bodyPr wrap="square" rtlCol="0" anchor="ctr"/>
+          <a:lstStyle/>
+          <a:p>
+            <a:pPr algn="l" indent="0" marL="0">
+              <a:buNone/>
+            </a:pPr>
+            <a:r>
+              <a:rPr lang="en-US" sz="1300" b="1" dirty="0">
+                <a:solidFill>
+                  <a:srgbClr val="13233A"/>
+                </a:solidFill>
+                <a:latin typeface="Consolas" pitchFamily="34" charset="0"/>
+                <a:ea typeface="Consolas" pitchFamily="34" charset="-122"/>
+                <a:cs typeface="Consolas" pitchFamily="34" charset="-120"/>
+              </a:rPr>
+              <a:t>기본</a:t>
+            </a:r>
+            <a:endParaRPr lang="en-US" sz="1300" dirty="0"/>
+          </a:p>
+        </p:txBody>
+      </p:sp>
+      <p:sp>
+        <p:nvSpPr>
+          <p:cNvPr id="13" name="Text 10"/>
+          <p:cNvSpPr/>
+          <p:nvPr/>
+        </p:nvSpPr>
+        <p:spPr>
+          <a:xfrm>
+            <a:off x="2194560" y="5641848"/>
+            <a:ext cx="2240280" cy="365760"/>
+          </a:xfrm>
+          <a:prstGeom prst="rect">
+            <a:avLst/>
+          </a:prstGeom>
+          <a:noFill/>
+          <a:ln/>
+        </p:spPr>
+        <p:txBody>
+          <a:bodyPr wrap="square" rtlCol="0" anchor="ctr"/>
+          <a:lstStyle/>
+          <a:p>
+            <a:pPr algn="ctr" indent="0" marL="0">
+              <a:buNone/>
+            </a:pPr>
+            <a:r>
+              <a:rPr lang="en-US" sz="1300" dirty="0">
+                <a:solidFill>
+                  <a:srgbClr val="13233A"/>
+                </a:solidFill>
+                <a:latin typeface="Consolas" pitchFamily="34" charset="0"/>
+                <a:ea typeface="Consolas" pitchFamily="34" charset="-122"/>
+                <a:cs typeface="Consolas" pitchFamily="34" charset="-120"/>
+              </a:rPr>
+              <a:t>0.64</a:t>
+            </a:r>
+            <a:endParaRPr lang="en-US" sz="1300" dirty="0"/>
+          </a:p>
+        </p:txBody>
+      </p:sp>
+      <p:sp>
+        <p:nvSpPr>
+          <p:cNvPr id="14" name="Text 11"/>
+          <p:cNvSpPr/>
+          <p:nvPr/>
+        </p:nvSpPr>
+        <p:spPr>
+          <a:xfrm>
+            <a:off x="4434840" y="5641848"/>
+            <a:ext cx="2240280" cy="365760"/>
+          </a:xfrm>
+          <a:prstGeom prst="rect">
+            <a:avLst/>
+          </a:prstGeom>
+          <a:noFill/>
+          <a:ln/>
+        </p:spPr>
+        <p:txBody>
+          <a:bodyPr wrap="square" rtlCol="0" anchor="ctr"/>
+          <a:lstStyle/>
+          <a:p>
+            <a:pPr algn="ctr" indent="0" marL="0">
+              <a:buNone/>
+            </a:pPr>
+            <a:r>
+              <a:rPr lang="en-US" sz="1300" dirty="0">
+                <a:solidFill>
+                  <a:srgbClr val="13233A"/>
+                </a:solidFill>
+                <a:latin typeface="Consolas" pitchFamily="34" charset="0"/>
+                <a:ea typeface="Consolas" pitchFamily="34" charset="-122"/>
+                <a:cs typeface="Consolas" pitchFamily="34" charset="-120"/>
+              </a:rPr>
+              <a:t>0.44</a:t>
+            </a:r>
+            <a:endParaRPr lang="en-US" sz="1300" dirty="0"/>
+          </a:p>
+        </p:txBody>
+      </p:sp>
+      <p:sp>
+        <p:nvSpPr>
+          <p:cNvPr id="15" name="Text 12"/>
+          <p:cNvSpPr/>
+          <p:nvPr/>
+        </p:nvSpPr>
+        <p:spPr>
+          <a:xfrm>
+            <a:off x="6675120" y="5641848"/>
+            <a:ext cx="2240280" cy="365760"/>
+          </a:xfrm>
+          <a:prstGeom prst="rect">
+            <a:avLst/>
+          </a:prstGeom>
+          <a:noFill/>
+          <a:ln/>
+        </p:spPr>
+        <p:txBody>
+          <a:bodyPr wrap="square" rtlCol="0" anchor="ctr"/>
+          <a:lstStyle/>
+          <a:p>
+            <a:pPr algn="ctr" indent="0" marL="0">
+              <a:buNone/>
+            </a:pPr>
+            <a:r>
+              <a:rPr lang="en-US" sz="1300" dirty="0">
+                <a:solidFill>
+                  <a:srgbClr val="13233A"/>
+                </a:solidFill>
+                <a:latin typeface="Consolas" pitchFamily="34" charset="0"/>
+                <a:ea typeface="Consolas" pitchFamily="34" charset="-122"/>
+                <a:cs typeface="Consolas" pitchFamily="34" charset="-120"/>
+              </a:rPr>
+              <a:t>0.44</a:t>
+            </a:r>
+            <a:endParaRPr lang="en-US" sz="1300" dirty="0"/>
+          </a:p>
+        </p:txBody>
+      </p:sp>
+      <p:sp>
+        <p:nvSpPr>
+          <p:cNvPr id="16" name="Text 13"/>
+          <p:cNvSpPr/>
+          <p:nvPr/>
+        </p:nvSpPr>
+        <p:spPr>
+          <a:xfrm>
+            <a:off x="8915400" y="5641848"/>
+            <a:ext cx="2240280" cy="365760"/>
+          </a:xfrm>
+          <a:prstGeom prst="rect">
+            <a:avLst/>
+          </a:prstGeom>
+          <a:noFill/>
+          <a:ln/>
+        </p:spPr>
+        <p:txBody>
+          <a:bodyPr wrap="square" rtlCol="0" anchor="ctr"/>
+          <a:lstStyle/>
+          <a:p>
+            <a:pPr algn="ctr" indent="0" marL="0">
+              <a:buNone/>
+            </a:pPr>
+            <a:r>
+              <a:rPr lang="en-US" sz="1300" dirty="0">
+                <a:solidFill>
+                  <a:srgbClr val="D9534F"/>
+                </a:solidFill>
+                <a:latin typeface="Consolas" pitchFamily="34" charset="0"/>
+                <a:ea typeface="Consolas" pitchFamily="34" charset="-122"/>
+                <a:cs typeface="Consolas" pitchFamily="34" charset="-120"/>
+              </a:rPr>
+              <a:t>−0.12</a:t>
+            </a:r>
+            <a:endParaRPr lang="en-US" sz="1300" dirty="0"/>
+          </a:p>
+        </p:txBody>
+      </p:sp>
+      <p:sp>
+        <p:nvSpPr>
+          <p:cNvPr id="17" name="Text 14"/>
+          <p:cNvSpPr/>
+          <p:nvPr/>
+        </p:nvSpPr>
+        <p:spPr>
+          <a:xfrm>
+            <a:off x="640080" y="6025896"/>
+            <a:ext cx="1554480" cy="365760"/>
+          </a:xfrm>
+          <a:prstGeom prst="rect">
+            <a:avLst/>
+          </a:prstGeom>
+          <a:noFill/>
+          <a:ln/>
+        </p:spPr>
+        <p:txBody>
+          <a:bodyPr wrap="square" rtlCol="0" anchor="ctr"/>
+          <a:lstStyle/>
+          <a:p>
+            <a:pPr algn="l" indent="0" marL="0">
+              <a:buNone/>
+            </a:pPr>
+            <a:r>
+              <a:rPr lang="en-US" sz="1300" b="1" dirty="0">
+                <a:solidFill>
+                  <a:srgbClr val="13233A"/>
+                </a:solidFill>
+                <a:latin typeface="Consolas" pitchFamily="34" charset="0"/>
+                <a:ea typeface="Consolas" pitchFamily="34" charset="-122"/>
+                <a:cs typeface="Consolas" pitchFamily="34" charset="-120"/>
+              </a:rPr>
+              <a:t>+RH</a:t>
+            </a:r>
+            <a:endParaRPr lang="en-US" sz="1300" dirty="0"/>
+          </a:p>
+        </p:txBody>
+      </p:sp>
+      <p:sp>
+        <p:nvSpPr>
+          <p:cNvPr id="18" name="Text 15"/>
+          <p:cNvSpPr/>
+          <p:nvPr/>
+        </p:nvSpPr>
+        <p:spPr>
+          <a:xfrm>
+            <a:off x="2194560" y="6025896"/>
+            <a:ext cx="2240280" cy="365760"/>
+          </a:xfrm>
+          <a:prstGeom prst="rect">
+            <a:avLst/>
+          </a:prstGeom>
+          <a:noFill/>
+          <a:ln/>
+        </p:spPr>
+        <p:txBody>
+          <a:bodyPr wrap="square" rtlCol="0" anchor="ctr"/>
+          <a:lstStyle/>
+          <a:p>
+            <a:pPr algn="ctr" indent="0" marL="0">
+              <a:buNone/>
+            </a:pPr>
+            <a:r>
+              <a:rPr lang="en-US" sz="1300" dirty="0">
+                <a:solidFill>
+                  <a:srgbClr val="13233A"/>
+                </a:solidFill>
+                <a:latin typeface="Consolas" pitchFamily="34" charset="0"/>
+                <a:ea typeface="Consolas" pitchFamily="34" charset="-122"/>
+                <a:cs typeface="Consolas" pitchFamily="34" charset="-120"/>
+              </a:rPr>
+              <a:t>0.71</a:t>
+            </a:r>
+            <a:endParaRPr lang="en-US" sz="1300" dirty="0"/>
+          </a:p>
+        </p:txBody>
+      </p:sp>
+      <p:sp>
+        <p:nvSpPr>
+          <p:cNvPr id="19" name="Text 16"/>
+          <p:cNvSpPr/>
+          <p:nvPr/>
+        </p:nvSpPr>
+        <p:spPr>
+          <a:xfrm>
+            <a:off x="4434840" y="6025896"/>
+            <a:ext cx="2240280" cy="365760"/>
+          </a:xfrm>
+          <a:prstGeom prst="rect">
+            <a:avLst/>
+          </a:prstGeom>
+          <a:noFill/>
+          <a:ln/>
+        </p:spPr>
+        <p:txBody>
+          <a:bodyPr wrap="square" rtlCol="0" anchor="ctr"/>
+          <a:lstStyle/>
+          <a:p>
+            <a:pPr algn="ctr" indent="0" marL="0">
+              <a:buNone/>
+            </a:pPr>
+            <a:r>
+              <a:rPr lang="en-US" sz="1300" dirty="0">
+                <a:solidFill>
+                  <a:srgbClr val="13233A"/>
+                </a:solidFill>
+                <a:latin typeface="Consolas" pitchFamily="34" charset="0"/>
+                <a:ea typeface="Consolas" pitchFamily="34" charset="-122"/>
+                <a:cs typeface="Consolas" pitchFamily="34" charset="-120"/>
+              </a:rPr>
+              <a:t>0.48</a:t>
+            </a:r>
+            <a:endParaRPr lang="en-US" sz="1300" dirty="0"/>
+          </a:p>
+        </p:txBody>
+      </p:sp>
+      <p:sp>
+        <p:nvSpPr>
+          <p:cNvPr id="20" name="Text 17"/>
+          <p:cNvSpPr/>
+          <p:nvPr/>
+        </p:nvSpPr>
+        <p:spPr>
+          <a:xfrm>
+            <a:off x="6675120" y="6025896"/>
+            <a:ext cx="2240280" cy="365760"/>
+          </a:xfrm>
+          <a:prstGeom prst="rect">
+            <a:avLst/>
+          </a:prstGeom>
+          <a:noFill/>
+          <a:ln/>
+        </p:spPr>
+        <p:txBody>
+          <a:bodyPr wrap="square" rtlCol="0" anchor="ctr"/>
+          <a:lstStyle/>
+          <a:p>
+            <a:pPr algn="ctr" indent="0" marL="0">
+              <a:buNone/>
+            </a:pPr>
+            <a:r>
+              <a:rPr lang="en-US" sz="1300" dirty="0">
+                <a:solidFill>
+                  <a:srgbClr val="13233A"/>
+                </a:solidFill>
+                <a:latin typeface="Consolas" pitchFamily="34" charset="0"/>
+                <a:ea typeface="Consolas" pitchFamily="34" charset="-122"/>
+                <a:cs typeface="Consolas" pitchFamily="34" charset="-120"/>
+              </a:rPr>
+              <a:t>0.49</a:t>
+            </a:r>
+            <a:endParaRPr lang="en-US" sz="1300" dirty="0"/>
+          </a:p>
+        </p:txBody>
+      </p:sp>
+      <p:sp>
+        <p:nvSpPr>
+          <p:cNvPr id="21" name="Text 18"/>
+          <p:cNvSpPr/>
+          <p:nvPr/>
+        </p:nvSpPr>
+        <p:spPr>
+          <a:xfrm>
+            <a:off x="8915400" y="6025896"/>
+            <a:ext cx="2240280" cy="365760"/>
+          </a:xfrm>
+          <a:prstGeom prst="rect">
+            <a:avLst/>
+          </a:prstGeom>
+          <a:noFill/>
+          <a:ln/>
+        </p:spPr>
+        <p:txBody>
+          <a:bodyPr wrap="square" rtlCol="0" anchor="ctr"/>
+          <a:lstStyle/>
+          <a:p>
+            <a:pPr algn="ctr" indent="0" marL="0">
+              <a:buNone/>
+            </a:pPr>
+            <a:r>
+              <a:rPr lang="en-US" sz="1300" dirty="0">
+                <a:solidFill>
+                  <a:srgbClr val="2E8B6F"/>
+                </a:solidFill>
+                <a:latin typeface="Consolas" pitchFamily="34" charset="0"/>
+                <a:ea typeface="Consolas" pitchFamily="34" charset="-122"/>
+                <a:cs typeface="Consolas" pitchFamily="34" charset="-120"/>
+              </a:rPr>
+              <a:t>0.21</a:t>
+            </a:r>
+            <a:endParaRPr lang="en-US" sz="1300" dirty="0"/>
+          </a:p>
+        </p:txBody>
+      </p:sp>
+      <p:sp>
+        <p:nvSpPr>
+          <p:cNvPr id="22" name="Text 19"/>
+          <p:cNvSpPr/>
+          <p:nvPr/>
+        </p:nvSpPr>
+        <p:spPr>
+          <a:xfrm>
+            <a:off x="11430000" y="6419088"/>
+            <a:ext cx="548640" cy="320040"/>
+          </a:xfrm>
+          <a:prstGeom prst="rect">
+            <a:avLst/>
+          </a:prstGeom>
+          <a:noFill/>
+          <a:ln/>
+        </p:spPr>
+        <p:txBody>
+          <a:bodyPr wrap="square" rtlCol="0" anchor="ctr"/>
+          <a:lstStyle/>
+          <a:p>
+            <a:pPr algn="r" indent="0" marL="0">
+              <a:buNone/>
+            </a:pPr>
+            <a:r>
+              <a:rPr lang="en-US" sz="1100" dirty="0">
+                <a:solidFill>
+                  <a:srgbClr val="5A6B7B"/>
+                </a:solidFill>
+                <a:latin typeface="Calibri" pitchFamily="34" charset="0"/>
+                <a:ea typeface="Calibri" pitchFamily="34" charset="-122"/>
+                <a:cs typeface="Calibri" pitchFamily="34" charset="-120"/>
+              </a:rPr>
+              <a:t>42</a:t>
+            </a:r>
+            <a:endParaRPr lang="en-US" sz="1100" dirty="0"/>
+          </a:p>
+        </p:txBody>
+      </p:sp>
+    </p:spTree>
+  </p:cSld>
+  <p:clrMapOvr>
+    <a:masterClrMapping/>
+  </p:clrMapOvr>
+</p:sld>
+</file>
+
+<file path=ppt/slides/slide43.xml><?xml version="1.0" encoding="utf-8"?>
+<p:sld xmlns:a="http://schemas.openxmlformats.org/drawingml/2006/main" xmlns:r="http://schemas.openxmlformats.org/officeDocument/2006/relationships" xmlns:p="http://schemas.openxmlformats.org/presentationml/2006/main">
+  <p:cSld name="Slide 43">
+    <p:bg>
+      <p:bgPr>
+        <a:solidFill>
+          <a:srgbClr val="F4F7FB"/>
+        </a:solidFill>
+      </p:bgPr>
+    </p:bg>
+    <p:spTree>
+      <p:nvGrpSpPr>
+        <p:cNvPr id="1" name=""/>
+        <p:cNvGrpSpPr/>
+        <p:nvPr/>
+      </p:nvGrpSpPr>
+      <p:grpSpPr>
+        <a:xfrm>
+          <a:off x="0" y="0"/>
+          <a:ext cx="0" cy="0"/>
+          <a:chOff x="0" y="0"/>
+          <a:chExt cx="0" cy="0"/>
+        </a:xfrm>
+      </p:grpSpPr>
+      <p:sp>
+        <p:nvSpPr>
+          <p:cNvPr id="2" name="Text 0"/>
+          <p:cNvSpPr/>
+          <p:nvPr/>
+        </p:nvSpPr>
+        <p:spPr>
+          <a:xfrm>
+            <a:off x="640080" y="457200"/>
+            <a:ext cx="8229600" cy="320040"/>
+          </a:xfrm>
+          <a:prstGeom prst="rect">
+            <a:avLst/>
+          </a:prstGeom>
+          <a:noFill/>
+          <a:ln/>
+        </p:spPr>
+        <p:txBody>
+          <a:bodyPr wrap="square" rtlCol="0" anchor="ctr"/>
+          <a:lstStyle/>
+          <a:p>
+            <a:pPr indent="0" marL="0">
+              <a:buNone/>
+            </a:pPr>
+            <a:r>
+              <a:rPr lang="en-US" sz="1250" b="1" spc="200" kern="0" dirty="0">
+                <a:solidFill>
+                  <a:srgbClr val="1C7293"/>
+                </a:solidFill>
+                <a:latin typeface="Calibri" pitchFamily="34" charset="0"/>
+                <a:ea typeface="Calibri" pitchFamily="34" charset="-122"/>
+                <a:cs typeface="Calibri" pitchFamily="34" charset="-120"/>
+              </a:rPr>
+              <a:t>WHY &amp; LIMITS</a:t>
+            </a:r>
+            <a:endParaRPr lang="en-US" sz="1250" dirty="0"/>
+          </a:p>
+        </p:txBody>
+      </p:sp>
+      <p:sp>
+        <p:nvSpPr>
+          <p:cNvPr id="3" name="Text 1"/>
+          <p:cNvSpPr/>
+          <p:nvPr/>
+        </p:nvSpPr>
+        <p:spPr>
+          <a:xfrm>
+            <a:off x="640080" y="749808"/>
+            <a:ext cx="10972800" cy="822960"/>
+          </a:xfrm>
+          <a:prstGeom prst="rect">
+            <a:avLst/>
+          </a:prstGeom>
+          <a:noFill/>
+          <a:ln/>
+        </p:spPr>
+        <p:txBody>
+          <a:bodyPr wrap="square" rtlCol="0" anchor="ctr"/>
+          <a:lstStyle/>
+          <a:p>
+            <a:pPr indent="0" marL="0">
+              <a:buNone/>
+            </a:pPr>
+            <a:r>
+              <a:rPr lang="en-US" sz="3400" b="1" dirty="0">
+                <a:solidFill>
+                  <a:srgbClr val="13233A"/>
+                </a:solidFill>
+                <a:latin typeface="Cambria" pitchFamily="34" charset="0"/>
+                <a:ea typeface="Cambria" pitchFamily="34" charset="-122"/>
+                <a:cs typeface="Cambria" pitchFamily="34" charset="-120"/>
+              </a:rPr>
+              <a:t>왜 RH인가 · 정직한 한계</a:t>
+            </a:r>
+            <a:endParaRPr lang="en-US" sz="3400" dirty="0"/>
+          </a:p>
+        </p:txBody>
+      </p:sp>
+      <p:sp>
+        <p:nvSpPr>
+          <p:cNvPr id="4" name="Shape 2"/>
+          <p:cNvSpPr/>
+          <p:nvPr/>
+        </p:nvSpPr>
+        <p:spPr>
+          <a:xfrm>
+            <a:off x="640080" y="1828800"/>
+            <a:ext cx="5394960" cy="4114800"/>
+          </a:xfrm>
+          <a:prstGeom prst="roundRect">
+            <a:avLst>
+              <a:gd name="adj" fmla="val 2000"/>
+            </a:avLst>
+          </a:prstGeom>
+          <a:solidFill>
+            <a:srgbClr val="EFF7F4"/>
+          </a:solidFill>
+          <a:ln w="12700">
+            <a:solidFill>
+              <a:srgbClr val="E2E9F1"/>
+            </a:solidFill>
+            <a:prstDash val="solid"/>
+          </a:ln>
+          <a:effectLst>
+            <a:outerShdw sx="100000" sy="100000" kx="0" ky="0" algn="bl" rotWithShape="0" blurRad="101600" dist="38100" dir="5400000">
+              <a:srgbClr val="9AAEC2">
+                <a:alpha val="40000"/>
+              </a:srgbClr>
+            </a:outerShdw>
+          </a:effectLst>
+        </p:spPr>
+      </p:sp>
+      <p:sp>
+        <p:nvSpPr>
+          <p:cNvPr id="5" name="Text 3"/>
+          <p:cNvSpPr/>
+          <p:nvPr/>
+        </p:nvSpPr>
+        <p:spPr>
+          <a:xfrm>
+            <a:off x="914400" y="2148840"/>
+            <a:ext cx="4846320" cy="3657600"/>
+          </a:xfrm>
+          <a:prstGeom prst="rect">
+            <a:avLst/>
+          </a:prstGeom>
+          <a:noFill/>
+          <a:ln/>
+        </p:spPr>
+        <p:txBody>
+          <a:bodyPr wrap="square" rtlCol="0" anchor="t"/>
+          <a:lstStyle/>
+          <a:p>
+            <a:pPr indent="0" marL="0">
+              <a:spcAft>
+                <a:spcPts val="800"/>
+              </a:spcAft>
+              <a:buNone/>
+            </a:pPr>
+            <a:r>
+              <a:rPr lang="en-US" sz="1800" b="1" dirty="0">
+                <a:solidFill>
+                  <a:srgbClr val="2A9D8F"/>
+                </a:solidFill>
+                <a:latin typeface="Cambria" pitchFamily="34" charset="0"/>
+                <a:ea typeface="Cambria" pitchFamily="34" charset="-122"/>
+                <a:cs typeface="Cambria" pitchFamily="34" charset="-120"/>
+              </a:rPr>
+              <a:t>왜 상대습도가 버티나
+</a:t>
+            </a:r>
+            <a:endParaRPr lang="en-US" sz="1800" dirty="0"/>
+          </a:p>
+          <a:p>
+            <a:pPr indent="0" marL="0">
+              <a:buNone/>
+            </a:pPr>
+            <a:r>
+              <a:rPr lang="en-US" sz="1400" dirty="0">
+                <a:solidFill>
+                  <a:srgbClr val="13233A"/>
+                </a:solidFill>
+                <a:latin typeface="Consolas" pitchFamily="34" charset="0"/>
+                <a:ea typeface="Consolas" pitchFamily="34" charset="-122"/>
+                <a:cs typeface="Consolas" pitchFamily="34" charset="-120"/>
+              </a:rPr>
+              <a:t>RH = 수증기 ÷ (그 기온의 최대 수용량)
+</a:t>
+            </a:r>
+            <a:endParaRPr lang="en-US" sz="1800" dirty="0"/>
+          </a:p>
+          <a:p>
+            <a:pPr indent="0" marL="0">
+              <a:buNone/>
+            </a:pPr>
+            <a:r>
+              <a:rPr lang="en-US" sz="1450" dirty="0">
+                <a:solidFill>
+                  <a:srgbClr val="13233A"/>
+                </a:solidFill>
+              </a:rPr>
+              <a:t>기온이 올라도 이 '비율' 관계는 잘 안 변한다(climate-invariant). 그래서 더운 기후로 외삽해도 예측이 이어진다.
+</a:t>
+            </a:r>
+            <a:endParaRPr lang="en-US" sz="1800" dirty="0"/>
+          </a:p>
+          <a:p>
+            <a:pPr indent="0" marL="0">
+              <a:buNone/>
+            </a:pPr>
+            <a:r>
+              <a:rPr lang="en-US" sz="1450" b="1" dirty="0">
+                <a:solidFill>
+                  <a:srgbClr val="13233A"/>
+                </a:solidFill>
+              </a:rPr>
+              <a:t>→ 물리를 변수에 미리 새겨 넣은 효과.</a:t>
+            </a:r>
+            <a:endParaRPr lang="en-US" sz="1800" dirty="0"/>
+          </a:p>
+        </p:txBody>
+      </p:sp>
+      <p:sp>
+        <p:nvSpPr>
+          <p:cNvPr id="6" name="Shape 4"/>
+          <p:cNvSpPr/>
+          <p:nvPr/>
+        </p:nvSpPr>
+        <p:spPr>
+          <a:xfrm>
+            <a:off x="6355080" y="1828800"/>
+            <a:ext cx="5193792" cy="4114800"/>
+          </a:xfrm>
+          <a:prstGeom prst="roundRect">
+            <a:avLst>
+              <a:gd name="adj" fmla="val 2000"/>
+            </a:avLst>
+          </a:prstGeom>
+          <a:solidFill>
+            <a:srgbClr val="FBF3EF"/>
+          </a:solidFill>
+          <a:ln w="12700">
+            <a:solidFill>
+              <a:srgbClr val="E2E9F1"/>
+            </a:solidFill>
+            <a:prstDash val="solid"/>
+          </a:ln>
+          <a:effectLst>
+            <a:outerShdw sx="100000" sy="100000" kx="0" ky="0" algn="bl" rotWithShape="0" blurRad="101600" dist="38100" dir="5400000">
+              <a:srgbClr val="9AAEC2">
+                <a:alpha val="40000"/>
+              </a:srgbClr>
+            </a:outerShdw>
+          </a:effectLst>
+        </p:spPr>
+      </p:sp>
+      <p:sp>
+        <p:nvSpPr>
+          <p:cNvPr id="7" name="Text 5"/>
+          <p:cNvSpPr/>
+          <p:nvPr/>
+        </p:nvSpPr>
+        <p:spPr>
+          <a:xfrm>
+            <a:off x="6629400" y="2148840"/>
+            <a:ext cx="4663440" cy="3657600"/>
+          </a:xfrm>
+          <a:prstGeom prst="rect">
+            <a:avLst/>
+          </a:prstGeom>
+          <a:noFill/>
+          <a:ln/>
+        </p:spPr>
+        <p:txBody>
+          <a:bodyPr wrap="square" rtlCol="0" anchor="t"/>
+          <a:lstStyle/>
+          <a:p>
+            <a:pPr indent="0" marL="0">
+              <a:spcAft>
+                <a:spcPts val="800"/>
+              </a:spcAft>
+              <a:buNone/>
+            </a:pPr>
+            <a:r>
+              <a:rPr lang="en-US" sz="1800" b="1" dirty="0">
+                <a:solidFill>
+                  <a:srgbClr val="E76F51"/>
+                </a:solidFill>
+                <a:latin typeface="Cambria" pitchFamily="34" charset="0"/>
+                <a:ea typeface="Cambria" pitchFamily="34" charset="-122"/>
+                <a:cs typeface="Cambria" pitchFamily="34" charset="-120"/>
+              </a:rPr>
+              <a:t>정직한 한계 (스스로 밝힘)
+</a:t>
+            </a:r>
+            <a:endParaRPr lang="en-US" sz="1800" dirty="0"/>
+          </a:p>
+          <a:p>
+            <a:pPr indent="0" marL="0">
+              <a:spcAft>
+                <a:spcPts val="500"/>
+              </a:spcAft>
+              <a:buNone/>
+            </a:pPr>
+            <a:r>
+              <a:rPr lang="en-US" sz="1350" dirty="0">
+                <a:solidFill>
+                  <a:srgbClr val="13233A"/>
+                </a:solidFill>
+              </a:rPr>
+              <a:t>• 온도밴드는 지역·계절 분포이동 — 실제 +4°C 온난화와는 다름(방향성 실험)
+</a:t>
+            </a:r>
+            <a:endParaRPr lang="en-US" sz="1800" dirty="0"/>
+          </a:p>
+          <a:p>
+            <a:pPr indent="0" marL="0">
+              <a:spcAft>
+                <a:spcPts val="500"/>
+              </a:spcAft>
+              <a:buNone/>
+            </a:pPr>
+            <a:r>
+              <a:rPr lang="en-US" sz="1350" dirty="0">
+                <a:solidFill>
+                  <a:srgbClr val="13233A"/>
+                </a:solidFill>
+              </a:rPr>
+              <a:t>• RH는 습도→강수 경로만 살림(전체 수증기 경향은 여전히 낮음)
+</a:t>
+            </a:r>
+            <a:endParaRPr lang="en-US" sz="1800" dirty="0"/>
+          </a:p>
+          <a:p>
+            <a:pPr indent="0" marL="0">
+              <a:buNone/>
+            </a:pPr>
+            <a:r>
+              <a:rPr lang="en-US" sz="1350" dirty="0">
+                <a:solidFill>
+                  <a:srgbClr val="13233A"/>
+                </a:solidFill>
+              </a:rPr>
+              <a:t>• seed 5개 — 더 많으면 좋음. 대조군(비물리 피처) 추가 시 인과 확실
+</a:t>
+            </a:r>
+            <a:endParaRPr lang="en-US" sz="1800" dirty="0"/>
+          </a:p>
+          <a:p>
+            <a:pPr indent="0" marL="0">
+              <a:buNone/>
+            </a:pPr>
+            <a:r>
+              <a:rPr lang="en-US" sz="1300" b="1" i="1" dirty="0">
+                <a:solidFill>
+                  <a:srgbClr val="1C4E80"/>
+                </a:solidFill>
+              </a:rPr>
+              <a:t>선행연구와 일치: Beucler 외, 'Climate-invariant ML', Sci. Adv. 2024</a:t>
+            </a:r>
+            <a:endParaRPr lang="en-US" sz="1800" dirty="0"/>
+          </a:p>
+        </p:txBody>
+      </p:sp>
+      <p:sp>
+        <p:nvSpPr>
+          <p:cNvPr id="8" name="Text 6"/>
+          <p:cNvSpPr/>
+          <p:nvPr/>
+        </p:nvSpPr>
+        <p:spPr>
+          <a:xfrm>
+            <a:off x="11430000" y="6419088"/>
+            <a:ext cx="548640" cy="320040"/>
+          </a:xfrm>
+          <a:prstGeom prst="rect">
+            <a:avLst/>
+          </a:prstGeom>
+          <a:noFill/>
+          <a:ln/>
+        </p:spPr>
+        <p:txBody>
+          <a:bodyPr wrap="square" rtlCol="0" anchor="ctr"/>
+          <a:lstStyle/>
+          <a:p>
+            <a:pPr algn="r" indent="0" marL="0">
+              <a:buNone/>
+            </a:pPr>
+            <a:r>
+              <a:rPr lang="en-US" sz="1100" dirty="0">
+                <a:solidFill>
+                  <a:srgbClr val="5A6B7B"/>
+                </a:solidFill>
+                <a:latin typeface="Calibri" pitchFamily="34" charset="0"/>
+                <a:ea typeface="Calibri" pitchFamily="34" charset="-122"/>
+                <a:cs typeface="Calibri" pitchFamily="34" charset="-120"/>
+              </a:rPr>
+              <a:t>43</a:t>
+            </a:r>
+            <a:endParaRPr lang="en-US" sz="1100" dirty="0"/>
+          </a:p>
+        </p:txBody>
+      </p:sp>
+    </p:spTree>
+  </p:cSld>
+  <p:clrMapOvr>
+    <a:masterClrMapping/>
+  </p:clrMapOvr>
+</p:sld>
+</file>
+
+<file path=ppt/slides/slide44.xml><?xml version="1.0" encoding="utf-8"?>
+<p:sld xmlns:a="http://schemas.openxmlformats.org/drawingml/2006/main" xmlns:r="http://schemas.openxmlformats.org/officeDocument/2006/relationships" xmlns:p="http://schemas.openxmlformats.org/presentationml/2006/main">
+  <p:cSld name="Slide 44">
+    <p:spTree>
+      <p:nvGrpSpPr>
+        <p:cNvPr id="1" name=""/>
+        <p:cNvGrpSpPr/>
+        <p:nvPr/>
+      </p:nvGrpSpPr>
+      <p:grpSpPr>
+        <a:xfrm>
+          <a:off x="0" y="0"/>
+          <a:ext cx="0" cy="0"/>
+          <a:chOff x="0" y="0"/>
+          <a:chExt cx="0" cy="0"/>
+        </a:xfrm>
+      </p:grpSpPr>
+      <p:pic>
+        <p:nvPicPr>
+          <p:cNvPr id="2" name="Image 0" descr="img/bg_section.png">    </p:cNvPr>
+          <p:cNvPicPr>
+            <a:picLocks noChangeAspect="1"/>
+          </p:cNvPicPr>
+          <p:nvPr/>
+        </p:nvPicPr>
+        <p:blipFill>
+          <a:blip r:embed="rId1"/>
+          <a:stretch>
+            <a:fillRect/>
+          </a:stretch>
+        </p:blipFill>
+        <p:spPr>
+          <a:xfrm>
+            <a:off x="0" y="0"/>
+            <a:ext cx="12188952" cy="6858000"/>
+          </a:xfrm>
+          <a:prstGeom prst="rect">
+            <a:avLst/>
+          </a:prstGeom>
+        </p:spPr>
+      </p:pic>
+      <p:sp>
+        <p:nvSpPr>
+          <p:cNvPr id="3" name="Shape 0"/>
+          <p:cNvSpPr/>
+          <p:nvPr/>
+        </p:nvSpPr>
+        <p:spPr>
+          <a:xfrm>
+            <a:off x="868680" y="2148840"/>
+            <a:ext cx="822960" cy="82296"/>
+          </a:xfrm>
+          <a:prstGeom prst="roundRect">
+            <a:avLst>
+              <a:gd name="adj" fmla="val 44444"/>
+            </a:avLst>
+          </a:prstGeom>
+          <a:solidFill>
+            <a:srgbClr val="E9A63B"/>
+          </a:solidFill>
+          <a:ln/>
+        </p:spPr>
+      </p:sp>
+      <p:sp>
+        <p:nvSpPr>
+          <p:cNvPr id="4" name="Text 1"/>
+          <p:cNvSpPr/>
+          <p:nvPr/>
+        </p:nvSpPr>
+        <p:spPr>
+          <a:xfrm>
+            <a:off x="822960" y="2286000"/>
+            <a:ext cx="5486400" cy="457200"/>
+          </a:xfrm>
+          <a:prstGeom prst="rect">
+            <a:avLst/>
+          </a:prstGeom>
+          <a:noFill/>
+          <a:ln/>
+        </p:spPr>
+        <p:txBody>
+          <a:bodyPr wrap="square" rtlCol="0" anchor="ctr"/>
+          <a:lstStyle/>
+          <a:p>
+            <a:pPr indent="0" marL="0">
+              <a:buNone/>
+            </a:pPr>
+            <a:r>
+              <a:rPr lang="en-US" sz="1800" b="1" spc="300" kern="0" dirty="0">
+                <a:solidFill>
+                  <a:srgbClr val="E9A63B"/>
+                </a:solidFill>
+                <a:latin typeface="Calibri" pitchFamily="34" charset="0"/>
+                <a:ea typeface="Calibri" pitchFamily="34" charset="-122"/>
+                <a:cs typeface="Calibri" pitchFamily="34" charset="-120"/>
+              </a:rPr>
+              <a:t>SECTION 결론</a:t>
+            </a:r>
+            <a:endParaRPr lang="en-US" sz="1800" dirty="0"/>
+          </a:p>
+        </p:txBody>
+      </p:sp>
+      <p:sp>
+        <p:nvSpPr>
+          <p:cNvPr id="5" name="Text 2"/>
+          <p:cNvSpPr/>
+          <p:nvPr/>
+        </p:nvSpPr>
+        <p:spPr>
+          <a:xfrm>
+            <a:off x="822960" y="2788920"/>
+            <a:ext cx="10515600" cy="1097280"/>
+          </a:xfrm>
+          <a:prstGeom prst="rect">
+            <a:avLst/>
+          </a:prstGeom>
+          <a:noFill/>
+          <a:ln/>
+        </p:spPr>
+        <p:txBody>
+          <a:bodyPr wrap="square" rtlCol="0" anchor="ctr"/>
+          <a:lstStyle/>
+          <a:p>
+            <a:pPr indent="0" marL="0">
+              <a:buNone/>
+            </a:pPr>
+            <a:r>
+              <a:rPr lang="en-US" sz="4400" b="1" dirty="0">
+                <a:solidFill>
+                  <a:srgbClr val="FFFFFF"/>
+                </a:solidFill>
+                <a:latin typeface="Cambria" pitchFamily="34" charset="0"/>
+                <a:ea typeface="Cambria" pitchFamily="34" charset="-122"/>
+                <a:cs typeface="Cambria" pitchFamily="34" charset="-120"/>
+              </a:rPr>
+              <a:t>마무리</a:t>
+            </a:r>
+            <a:endParaRPr lang="en-US" sz="4400" dirty="0"/>
+          </a:p>
+        </p:txBody>
+      </p:sp>
+      <p:sp>
+        <p:nvSpPr>
+          <p:cNvPr id="6" name="Text 3"/>
+          <p:cNvSpPr/>
+          <p:nvPr/>
+        </p:nvSpPr>
+        <p:spPr>
+          <a:xfrm>
+            <a:off x="822960" y="3977640"/>
+            <a:ext cx="10058400" cy="548640"/>
+          </a:xfrm>
+          <a:prstGeom prst="rect">
+            <a:avLst/>
+          </a:prstGeom>
+          <a:noFill/>
+          <a:ln/>
+        </p:spPr>
+        <p:txBody>
+          <a:bodyPr wrap="square" rtlCol="0" anchor="ctr"/>
+          <a:lstStyle/>
+          <a:p>
+            <a:pPr indent="0" marL="0">
+              <a:buNone/>
+            </a:pPr>
+            <a:r>
+              <a:rPr lang="en-US" sz="1800" dirty="0">
+                <a:solidFill>
+                  <a:srgbClr val="DCE7F5"/>
+                </a:solidFill>
+                <a:latin typeface="Calibri" pitchFamily="34" charset="0"/>
+                <a:ea typeface="Calibri" pitchFamily="34" charset="-122"/>
+                <a:cs typeface="Calibri" pitchFamily="34" charset="-120"/>
+              </a:rPr>
+              <a:t>핵심 교훈과 재현 가능한 파이프라인</a:t>
+            </a:r>
+            <a:endParaRPr lang="en-US" sz="1800" dirty="0"/>
+          </a:p>
+        </p:txBody>
+      </p:sp>
+    </p:spTree>
+  </p:cSld>
+  <p:clrMapOvr>
+    <a:masterClrMapping/>
+  </p:clrMapOvr>
+</p:sld>
+</file>
+
+<file path=ppt/slides/slide45.xml><?xml version="1.0" encoding="utf-8"?>
+<p:sld xmlns:a="http://schemas.openxmlformats.org/drawingml/2006/main" xmlns:r="http://schemas.openxmlformats.org/officeDocument/2006/relationships" xmlns:p="http://schemas.openxmlformats.org/presentationml/2006/main">
+  <p:cSld name="Slide 45">
+    <p:bg>
+      <p:bgPr>
+        <a:solidFill>
+          <a:srgbClr val="F4F7FB"/>
+        </a:solidFill>
+      </p:bgPr>
+    </p:bg>
+    <p:spTree>
+      <p:nvGrpSpPr>
+        <p:cNvPr id="1" name=""/>
+        <p:cNvGrpSpPr/>
+        <p:nvPr/>
+      </p:nvGrpSpPr>
+      <p:grpSpPr>
+        <a:xfrm>
+          <a:off x="0" y="0"/>
+          <a:ext cx="0" cy="0"/>
+          <a:chOff x="0" y="0"/>
+          <a:chExt cx="0" cy="0"/>
+        </a:xfrm>
+      </p:grpSpPr>
+      <p:sp>
+        <p:nvSpPr>
+          <p:cNvPr id="2" name="Text 0"/>
+          <p:cNvSpPr/>
+          <p:nvPr/>
+        </p:nvSpPr>
+        <p:spPr>
+          <a:xfrm>
+            <a:off x="640080" y="457200"/>
+            <a:ext cx="8229600" cy="320040"/>
+          </a:xfrm>
+          <a:prstGeom prst="rect">
+            <a:avLst/>
+          </a:prstGeom>
+          <a:noFill/>
+          <a:ln/>
+        </p:spPr>
+        <p:txBody>
+          <a:bodyPr wrap="square" rtlCol="0" anchor="ctr"/>
+          <a:lstStyle/>
+          <a:p>
+            <a:pPr indent="0" marL="0">
+              <a:buNone/>
+            </a:pPr>
+            <a:r>
+              <a:rPr lang="en-US" sz="1250" b="1" spc="200" kern="0" dirty="0">
+                <a:solidFill>
+                  <a:srgbClr val="1C7293"/>
+                </a:solidFill>
+                <a:latin typeface="Calibri" pitchFamily="34" charset="0"/>
+                <a:ea typeface="Calibri" pitchFamily="34" charset="-122"/>
+                <a:cs typeface="Calibri" pitchFamily="34" charset="-120"/>
+              </a:rPr>
+              <a:t>TAKEAWAYS</a:t>
+            </a:r>
+            <a:endParaRPr lang="en-US" sz="1250" dirty="0"/>
+          </a:p>
+        </p:txBody>
+      </p:sp>
+      <p:sp>
+        <p:nvSpPr>
+          <p:cNvPr id="3" name="Text 1"/>
+          <p:cNvSpPr/>
+          <p:nvPr/>
+        </p:nvSpPr>
+        <p:spPr>
+          <a:xfrm>
+            <a:off x="640080" y="749808"/>
+            <a:ext cx="10972800" cy="822960"/>
+          </a:xfrm>
+          <a:prstGeom prst="rect">
+            <a:avLst/>
+          </a:prstGeom>
+          <a:noFill/>
+          <a:ln/>
+        </p:spPr>
+        <p:txBody>
+          <a:bodyPr wrap="square" rtlCol="0" anchor="ctr"/>
+          <a:lstStyle/>
+          <a:p>
+            <a:pPr indent="0" marL="0">
+              <a:buNone/>
+            </a:pPr>
+            <a:r>
+              <a:rPr lang="en-US" sz="3400" b="1" dirty="0">
+                <a:solidFill>
+                  <a:srgbClr val="13233A"/>
+                </a:solidFill>
+                <a:latin typeface="Cambria" pitchFamily="34" charset="0"/>
+                <a:ea typeface="Cambria" pitchFamily="34" charset="-122"/>
+                <a:cs typeface="Cambria" pitchFamily="34" charset="-120"/>
+              </a:rPr>
+              <a:t>파이프라인이 준 세 가지 교훈</a:t>
+            </a:r>
+            <a:endParaRPr lang="en-US" sz="3400" dirty="0"/>
+          </a:p>
+        </p:txBody>
+      </p:sp>
+      <p:sp>
+        <p:nvSpPr>
+          <p:cNvPr id="4" name="Shape 2"/>
+          <p:cNvSpPr/>
+          <p:nvPr/>
+        </p:nvSpPr>
+        <p:spPr>
+          <a:xfrm>
+            <a:off x="640080" y="1828800"/>
+            <a:ext cx="10972800" cy="1234440"/>
+          </a:xfrm>
+          <a:prstGeom prst="roundRect">
+            <a:avLst>
+              <a:gd name="adj" fmla="val 6667"/>
+            </a:avLst>
+          </a:prstGeom>
+          <a:solidFill>
+            <a:srgbClr val="FFFFFF"/>
+          </a:solidFill>
+          <a:ln w="12700">
+            <a:solidFill>
+              <a:srgbClr val="E2E9F1"/>
+            </a:solidFill>
+            <a:prstDash val="solid"/>
+          </a:ln>
+          <a:effectLst>
+            <a:outerShdw sx="100000" sy="100000" kx="0" ky="0" algn="bl" rotWithShape="0" blurRad="101600" dist="38100" dir="5400000">
+              <a:srgbClr val="9AAEC2">
+                <a:alpha val="40000"/>
+              </a:srgbClr>
+            </a:outerShdw>
+          </a:effectLst>
+        </p:spPr>
+      </p:sp>
+      <p:sp>
+        <p:nvSpPr>
+          <p:cNvPr id="5" name="Shape 3"/>
+          <p:cNvSpPr/>
+          <p:nvPr/>
+        </p:nvSpPr>
+        <p:spPr>
+          <a:xfrm>
+            <a:off x="914400" y="2249424"/>
+            <a:ext cx="384048" cy="384048"/>
+          </a:xfrm>
+          <a:prstGeom prst="roundRect">
+            <a:avLst>
+              <a:gd name="adj" fmla="val 19048"/>
+            </a:avLst>
+          </a:prstGeom>
+          <a:solidFill>
+            <a:srgbClr val="1C4E80"/>
+          </a:solidFill>
+          <a:ln/>
+        </p:spPr>
+      </p:sp>
+      <p:sp>
+        <p:nvSpPr>
+          <p:cNvPr id="6" name="Text 4"/>
+          <p:cNvSpPr/>
+          <p:nvPr/>
+        </p:nvSpPr>
+        <p:spPr>
+          <a:xfrm>
+            <a:off x="914400" y="2249424"/>
+            <a:ext cx="384048" cy="384048"/>
+          </a:xfrm>
+          <a:prstGeom prst="rect">
+            <a:avLst/>
+          </a:prstGeom>
+          <a:noFill/>
+          <a:ln/>
+        </p:spPr>
+        <p:txBody>
+          <a:bodyPr wrap="square" rtlCol="0" anchor="ctr"/>
+          <a:lstStyle/>
+          <a:p>
+            <a:pPr algn="ctr" indent="0" marL="0">
+              <a:buNone/>
+            </a:pPr>
+            <a:r>
+              <a:rPr lang="en-US" sz="1600" b="1" dirty="0">
+                <a:solidFill>
+                  <a:srgbClr val="FFFFFF"/>
+                </a:solidFill>
+                <a:latin typeface="Cambria" pitchFamily="34" charset="0"/>
+                <a:ea typeface="Cambria" pitchFamily="34" charset="-122"/>
+                <a:cs typeface="Cambria" pitchFamily="34" charset="-120"/>
+              </a:rPr>
+              <a:t>1</a:t>
+            </a:r>
+            <a:endParaRPr lang="en-US" sz="1600" dirty="0"/>
+          </a:p>
+        </p:txBody>
+      </p:sp>
+      <p:sp>
+        <p:nvSpPr>
+          <p:cNvPr id="7" name="Text 5"/>
+          <p:cNvSpPr/>
+          <p:nvPr/>
+        </p:nvSpPr>
+        <p:spPr>
+          <a:xfrm>
+            <a:off x="1554480" y="2011680"/>
+            <a:ext cx="9875520" cy="457200"/>
+          </a:xfrm>
+          <a:prstGeom prst="rect">
+            <a:avLst/>
+          </a:prstGeom>
+          <a:noFill/>
+          <a:ln/>
+        </p:spPr>
+        <p:txBody>
+          <a:bodyPr wrap="square" rtlCol="0" anchor="ctr"/>
+          <a:lstStyle/>
+          <a:p>
+            <a:pPr indent="0" marL="0">
+              <a:buNone/>
+            </a:pPr>
+            <a:r>
+              <a:rPr lang="en-US" sz="1900" b="1" dirty="0">
+                <a:solidFill>
+                  <a:srgbClr val="13233A"/>
+                </a:solidFill>
+                <a:latin typeface="Cambria" pitchFamily="34" charset="0"/>
+                <a:ea typeface="Cambria" pitchFamily="34" charset="-122"/>
+                <a:cs typeface="Cambria" pitchFamily="34" charset="-120"/>
+              </a:rPr>
+              <a:t>데이터를 먼저 본다</a:t>
+            </a:r>
+            <a:endParaRPr lang="en-US" sz="1900" dirty="0"/>
+          </a:p>
+        </p:txBody>
+      </p:sp>
+      <p:sp>
+        <p:nvSpPr>
+          <p:cNvPr id="8" name="Text 6"/>
+          <p:cNvSpPr/>
+          <p:nvPr/>
+        </p:nvSpPr>
+        <p:spPr>
+          <a:xfrm>
+            <a:off x="1554480" y="2487168"/>
+            <a:ext cx="9692640" cy="502920"/>
+          </a:xfrm>
+          <a:prstGeom prst="rect">
+            <a:avLst/>
+          </a:prstGeom>
+          <a:noFill/>
+          <a:ln/>
+        </p:spPr>
+        <p:txBody>
+          <a:bodyPr wrap="square" rtlCol="0" anchor="ctr"/>
+          <a:lstStyle/>
+          <a:p>
+            <a:pPr indent="0" marL="0">
+              <a:buNone/>
+            </a:pPr>
+            <a:r>
+              <a:rPr lang="en-US" sz="1450" dirty="0">
+                <a:solidFill>
+                  <a:srgbClr val="5A6B7B"/>
+                </a:solidFill>
+                <a:latin typeface="Calibri" pitchFamily="34" charset="0"/>
+                <a:ea typeface="Calibri" pitchFamily="34" charset="-122"/>
+                <a:cs typeface="Calibri" pitchFamily="34" charset="-120"/>
+              </a:rPr>
+              <a:t>품질 점검·이상치 파악이 없으면 지표를 오해한다</a:t>
+            </a:r>
+            <a:endParaRPr lang="en-US" sz="1450" dirty="0"/>
+          </a:p>
+        </p:txBody>
+      </p:sp>
+      <p:sp>
+        <p:nvSpPr>
+          <p:cNvPr id="9" name="Shape 7"/>
+          <p:cNvSpPr/>
+          <p:nvPr/>
+        </p:nvSpPr>
+        <p:spPr>
+          <a:xfrm>
+            <a:off x="640080" y="3200400"/>
+            <a:ext cx="10972800" cy="1234440"/>
+          </a:xfrm>
+          <a:prstGeom prst="roundRect">
+            <a:avLst>
+              <a:gd name="adj" fmla="val 6667"/>
+            </a:avLst>
+          </a:prstGeom>
+          <a:solidFill>
+            <a:srgbClr val="FFFFFF"/>
+          </a:solidFill>
+          <a:ln w="12700">
+            <a:solidFill>
+              <a:srgbClr val="E2E9F1"/>
+            </a:solidFill>
+            <a:prstDash val="solid"/>
+          </a:ln>
+          <a:effectLst>
+            <a:outerShdw sx="100000" sy="100000" kx="0" ky="0" algn="bl" rotWithShape="0" blurRad="101600" dist="38100" dir="5400000">
+              <a:srgbClr val="9AAEC2">
+                <a:alpha val="40000"/>
+              </a:srgbClr>
+            </a:outerShdw>
+          </a:effectLst>
+        </p:spPr>
+      </p:sp>
+      <p:sp>
+        <p:nvSpPr>
+          <p:cNvPr id="10" name="Shape 8"/>
+          <p:cNvSpPr/>
+          <p:nvPr/>
+        </p:nvSpPr>
+        <p:spPr>
+          <a:xfrm>
+            <a:off x="914400" y="3621024"/>
+            <a:ext cx="384048" cy="384048"/>
+          </a:xfrm>
+          <a:prstGeom prst="roundRect">
+            <a:avLst>
+              <a:gd name="adj" fmla="val 19048"/>
+            </a:avLst>
+          </a:prstGeom>
+          <a:solidFill>
+            <a:srgbClr val="E76F51"/>
+          </a:solidFill>
+          <a:ln/>
+        </p:spPr>
+      </p:sp>
+      <p:sp>
+        <p:nvSpPr>
+          <p:cNvPr id="11" name="Text 9"/>
+          <p:cNvSpPr/>
+          <p:nvPr/>
+        </p:nvSpPr>
+        <p:spPr>
+          <a:xfrm>
+            <a:off x="914400" y="3621024"/>
+            <a:ext cx="384048" cy="384048"/>
+          </a:xfrm>
+          <a:prstGeom prst="rect">
+            <a:avLst/>
+          </a:prstGeom>
+          <a:noFill/>
+          <a:ln/>
+        </p:spPr>
+        <p:txBody>
+          <a:bodyPr wrap="square" rtlCol="0" anchor="ctr"/>
+          <a:lstStyle/>
+          <a:p>
+            <a:pPr algn="ctr" indent="0" marL="0">
+              <a:buNone/>
+            </a:pPr>
+            <a:r>
+              <a:rPr lang="en-US" sz="1600" b="1" dirty="0">
+                <a:solidFill>
+                  <a:srgbClr val="FFFFFF"/>
+                </a:solidFill>
+                <a:latin typeface="Cambria" pitchFamily="34" charset="0"/>
+                <a:ea typeface="Cambria" pitchFamily="34" charset="-122"/>
+                <a:cs typeface="Cambria" pitchFamily="34" charset="-120"/>
+              </a:rPr>
+              <a:t>2</a:t>
+            </a:r>
+            <a:endParaRPr lang="en-US" sz="1600" dirty="0"/>
+          </a:p>
+        </p:txBody>
+      </p:sp>
+      <p:sp>
+        <p:nvSpPr>
+          <p:cNvPr id="12" name="Text 10"/>
+          <p:cNvSpPr/>
+          <p:nvPr/>
+        </p:nvSpPr>
+        <p:spPr>
+          <a:xfrm>
+            <a:off x="1554480" y="3383280"/>
+            <a:ext cx="9875520" cy="457200"/>
+          </a:xfrm>
+          <a:prstGeom prst="rect">
+            <a:avLst/>
+          </a:prstGeom>
+          <a:noFill/>
+          <a:ln/>
+        </p:spPr>
+        <p:txBody>
+          <a:bodyPr wrap="square" rtlCol="0" anchor="ctr"/>
+          <a:lstStyle/>
+          <a:p>
+            <a:pPr indent="0" marL="0">
+              <a:buNone/>
+            </a:pPr>
+            <a:r>
+              <a:rPr lang="en-US" sz="1900" b="1" dirty="0">
+                <a:solidFill>
+                  <a:srgbClr val="13233A"/>
+                </a:solidFill>
+                <a:latin typeface="Cambria" pitchFamily="34" charset="0"/>
+                <a:ea typeface="Cambria" pitchFamily="34" charset="-122"/>
+                <a:cs typeface="Cambria" pitchFamily="34" charset="-120"/>
+              </a:rPr>
+              <a:t>지표를 올바로 고른다</a:t>
+            </a:r>
+            <a:endParaRPr lang="en-US" sz="1900" dirty="0"/>
+          </a:p>
+        </p:txBody>
+      </p:sp>
+      <p:sp>
+        <p:nvSpPr>
+          <p:cNvPr id="13" name="Text 11"/>
+          <p:cNvSpPr/>
+          <p:nvPr/>
+        </p:nvSpPr>
+        <p:spPr>
+          <a:xfrm>
+            <a:off x="1554480" y="3858768"/>
+            <a:ext cx="9692640" cy="502920"/>
+          </a:xfrm>
+          <a:prstGeom prst="rect">
+            <a:avLst/>
+          </a:prstGeom>
+          <a:noFill/>
+          <a:ln/>
+        </p:spPr>
+        <p:txBody>
+          <a:bodyPr wrap="square" rtlCol="0" anchor="ctr"/>
+          <a:lstStyle/>
+          <a:p>
+            <a:pPr indent="0" marL="0">
+              <a:buNone/>
+            </a:pPr>
+            <a:r>
+              <a:rPr lang="en-US" sz="1450" dirty="0">
+                <a:solidFill>
+                  <a:srgbClr val="5A6B7B"/>
+                </a:solidFill>
+                <a:latin typeface="Calibri" pitchFamily="34" charset="0"/>
+                <a:ea typeface="Calibri" pitchFamily="34" charset="-122"/>
+                <a:cs typeface="Calibri" pitchFamily="34" charset="-120"/>
+              </a:rPr>
+              <a:t>단순평균 R²의 함정 → 분산가중 R²와 그룹별 평가</a:t>
+            </a:r>
+            <a:endParaRPr lang="en-US" sz="1450" dirty="0"/>
+          </a:p>
+        </p:txBody>
+      </p:sp>
+      <p:sp>
+        <p:nvSpPr>
+          <p:cNvPr id="14" name="Shape 12"/>
+          <p:cNvSpPr/>
+          <p:nvPr/>
+        </p:nvSpPr>
+        <p:spPr>
+          <a:xfrm>
+            <a:off x="640080" y="4572000"/>
+            <a:ext cx="10972800" cy="1234440"/>
+          </a:xfrm>
+          <a:prstGeom prst="roundRect">
+            <a:avLst>
+              <a:gd name="adj" fmla="val 6667"/>
+            </a:avLst>
+          </a:prstGeom>
+          <a:solidFill>
+            <a:srgbClr val="FFFFFF"/>
+          </a:solidFill>
+          <a:ln w="12700">
+            <a:solidFill>
+              <a:srgbClr val="E2E9F1"/>
+            </a:solidFill>
+            <a:prstDash val="solid"/>
+          </a:ln>
+          <a:effectLst>
+            <a:outerShdw sx="100000" sy="100000" kx="0" ky="0" algn="bl" rotWithShape="0" blurRad="101600" dist="38100" dir="5400000">
+              <a:srgbClr val="9AAEC2">
+                <a:alpha val="40000"/>
+              </a:srgbClr>
+            </a:outerShdw>
+          </a:effectLst>
+        </p:spPr>
+      </p:sp>
+      <p:sp>
+        <p:nvSpPr>
+          <p:cNvPr id="15" name="Shape 13"/>
+          <p:cNvSpPr/>
+          <p:nvPr/>
+        </p:nvSpPr>
+        <p:spPr>
+          <a:xfrm>
+            <a:off x="914400" y="4992624"/>
+            <a:ext cx="384048" cy="384048"/>
+          </a:xfrm>
+          <a:prstGeom prst="roundRect">
+            <a:avLst>
+              <a:gd name="adj" fmla="val 19048"/>
+            </a:avLst>
+          </a:prstGeom>
+          <a:solidFill>
+            <a:srgbClr val="2A9D8F"/>
+          </a:solidFill>
+          <a:ln/>
+        </p:spPr>
+      </p:sp>
+      <p:sp>
+        <p:nvSpPr>
+          <p:cNvPr id="16" name="Text 14"/>
+          <p:cNvSpPr/>
+          <p:nvPr/>
+        </p:nvSpPr>
+        <p:spPr>
+          <a:xfrm>
+            <a:off x="914400" y="4992624"/>
+            <a:ext cx="384048" cy="384048"/>
+          </a:xfrm>
+          <a:prstGeom prst="rect">
+            <a:avLst/>
+          </a:prstGeom>
+          <a:noFill/>
+          <a:ln/>
+        </p:spPr>
+        <p:txBody>
+          <a:bodyPr wrap="square" rtlCol="0" anchor="ctr"/>
+          <a:lstStyle/>
+          <a:p>
+            <a:pPr algn="ctr" indent="0" marL="0">
+              <a:buNone/>
+            </a:pPr>
+            <a:r>
+              <a:rPr lang="en-US" sz="1600" b="1" dirty="0">
+                <a:solidFill>
+                  <a:srgbClr val="FFFFFF"/>
+                </a:solidFill>
+                <a:latin typeface="Cambria" pitchFamily="34" charset="0"/>
+                <a:ea typeface="Cambria" pitchFamily="34" charset="-122"/>
+                <a:cs typeface="Cambria" pitchFamily="34" charset="-120"/>
+              </a:rPr>
+              <a:t>3</a:t>
+            </a:r>
+            <a:endParaRPr lang="en-US" sz="1600" dirty="0"/>
+          </a:p>
+        </p:txBody>
+      </p:sp>
+      <p:sp>
+        <p:nvSpPr>
+          <p:cNvPr id="17" name="Text 15"/>
+          <p:cNvSpPr/>
+          <p:nvPr/>
+        </p:nvSpPr>
+        <p:spPr>
+          <a:xfrm>
+            <a:off x="1554480" y="4754880"/>
+            <a:ext cx="9875520" cy="457200"/>
+          </a:xfrm>
+          <a:prstGeom prst="rect">
+            <a:avLst/>
+          </a:prstGeom>
+          <a:noFill/>
+          <a:ln/>
+        </p:spPr>
+        <p:txBody>
+          <a:bodyPr wrap="square" rtlCol="0" anchor="ctr"/>
+          <a:lstStyle/>
+          <a:p>
+            <a:pPr indent="0" marL="0">
+              <a:buNone/>
+            </a:pPr>
+            <a:r>
+              <a:rPr lang="en-US" sz="1900" b="1" dirty="0">
+                <a:solidFill>
+                  <a:srgbClr val="13233A"/>
+                </a:solidFill>
+                <a:latin typeface="Cambria" pitchFamily="34" charset="0"/>
+                <a:ea typeface="Cambria" pitchFamily="34" charset="-122"/>
+                <a:cs typeface="Cambria" pitchFamily="34" charset="-120"/>
+              </a:rPr>
+              <a:t>변수가 모델을, 물리가 미래를 살린다</a:t>
+            </a:r>
+            <a:endParaRPr lang="en-US" sz="1900" dirty="0"/>
+          </a:p>
+        </p:txBody>
+      </p:sp>
+      <p:sp>
+        <p:nvSpPr>
+          <p:cNvPr id="18" name="Text 16"/>
+          <p:cNvSpPr/>
+          <p:nvPr/>
+        </p:nvSpPr>
+        <p:spPr>
+          <a:xfrm>
+            <a:off x="1554480" y="5230368"/>
+            <a:ext cx="9692640" cy="502920"/>
+          </a:xfrm>
+          <a:prstGeom prst="rect">
+            <a:avLst/>
+          </a:prstGeom>
+          <a:noFill/>
+          <a:ln/>
+        </p:spPr>
+        <p:txBody>
+          <a:bodyPr wrap="square" rtlCol="0" anchor="ctr"/>
+          <a:lstStyle/>
+          <a:p>
+            <a:pPr indent="0" marL="0">
+              <a:buNone/>
+            </a:pPr>
+            <a:r>
+              <a:rPr lang="en-US" sz="1450" dirty="0">
+                <a:solidFill>
+                  <a:srgbClr val="5A6B7B"/>
+                </a:solidFill>
+                <a:latin typeface="Calibri" pitchFamily="34" charset="0"/>
+                <a:ea typeface="Calibri" pitchFamily="34" charset="-122"/>
+                <a:cs typeface="Calibri" pitchFamily="34" charset="-120"/>
+              </a:rPr>
+              <a:t>물리 파생변수(RH)는 모델 교체를 이기고, 배운 적 없는 더운 기후에서도 예측을 지켰다</a:t>
+            </a:r>
+            <a:endParaRPr lang="en-US" sz="1450" dirty="0"/>
+          </a:p>
+        </p:txBody>
+      </p:sp>
+      <p:sp>
+        <p:nvSpPr>
+          <p:cNvPr id="19" name="Text 17"/>
+          <p:cNvSpPr/>
+          <p:nvPr/>
+        </p:nvSpPr>
+        <p:spPr>
+          <a:xfrm>
+            <a:off x="11430000" y="6419088"/>
+            <a:ext cx="548640" cy="320040"/>
+          </a:xfrm>
+          <a:prstGeom prst="rect">
+            <a:avLst/>
+          </a:prstGeom>
+          <a:noFill/>
+          <a:ln/>
+        </p:spPr>
+        <p:txBody>
+          <a:bodyPr wrap="square" rtlCol="0" anchor="ctr"/>
+          <a:lstStyle/>
+          <a:p>
+            <a:pPr algn="r" indent="0" marL="0">
+              <a:buNone/>
+            </a:pPr>
+            <a:r>
+              <a:rPr lang="en-US" sz="1100" dirty="0">
+                <a:solidFill>
+                  <a:srgbClr val="5A6B7B"/>
+                </a:solidFill>
+                <a:latin typeface="Calibri" pitchFamily="34" charset="0"/>
+                <a:ea typeface="Calibri" pitchFamily="34" charset="-122"/>
+                <a:cs typeface="Calibri" pitchFamily="34" charset="-120"/>
+              </a:rPr>
+              <a:t>45</a:t>
+            </a:r>
+            <a:endParaRPr lang="en-US" sz="1100" dirty="0"/>
+          </a:p>
+        </p:txBody>
+      </p:sp>
+    </p:spTree>
+  </p:cSld>
+  <p:clrMapOvr>
+    <a:masterClrMapping/>
+  </p:clrMapOvr>
+</p:sld>
+</file>
+
+<file path=ppt/slides/slide46.xml><?xml version="1.0" encoding="utf-8"?>
+<p:sld xmlns:a="http://schemas.openxmlformats.org/drawingml/2006/main" xmlns:r="http://schemas.openxmlformats.org/officeDocument/2006/relationships" xmlns:p="http://schemas.openxmlformats.org/presentationml/2006/main">
+  <p:cSld name="Slide 46">
+    <p:bg>
+      <p:bgPr>
+        <a:solidFill>
+          <a:srgbClr val="F4F7FB"/>
+        </a:solidFill>
+      </p:bgPr>
+    </p:bg>
+    <p:spTree>
+      <p:nvGrpSpPr>
+        <p:cNvPr id="1" name=""/>
+        <p:cNvGrpSpPr/>
+        <p:nvPr/>
+      </p:nvGrpSpPr>
+      <p:grpSpPr>
+        <a:xfrm>
+          <a:off x="0" y="0"/>
+          <a:ext cx="0" cy="0"/>
+          <a:chOff x="0" y="0"/>
+          <a:chExt cx="0" cy="0"/>
+        </a:xfrm>
+      </p:grpSpPr>
+      <p:sp>
+        <p:nvSpPr>
+          <p:cNvPr id="2" name="Text 0"/>
+          <p:cNvSpPr/>
+          <p:nvPr/>
+        </p:nvSpPr>
+        <p:spPr>
+          <a:xfrm>
+            <a:off x="640080" y="457200"/>
+            <a:ext cx="8229600" cy="320040"/>
+          </a:xfrm>
+          <a:prstGeom prst="rect">
+            <a:avLst/>
+          </a:prstGeom>
+          <a:noFill/>
+          <a:ln/>
+        </p:spPr>
+        <p:txBody>
+          <a:bodyPr wrap="square" rtlCol="0" anchor="ctr"/>
+          <a:lstStyle/>
+          <a:p>
+            <a:pPr indent="0" marL="0">
+              <a:buNone/>
+            </a:pPr>
+            <a:r>
+              <a:rPr lang="en-US" sz="1250" b="1" spc="200" kern="0" dirty="0">
+                <a:solidFill>
                   <a:srgbClr val="1C7293"/>
                 </a:solidFill>
                 <a:latin typeface="Calibri" pitchFamily="34" charset="0"/>
@@ -19456,7 +22426,7 @@
                 <a:ea typeface="Calibri" pitchFamily="34" charset="-122"/>
                 <a:cs typeface="Calibri" pitchFamily="34" charset="-120"/>
               </a:rPr>
-              <a:t>40</a:t>
+              <a:t>46</a:t>
             </a:r>
             <a:endParaRPr lang="en-US" sz="1100" dirty="0"/>
           </a:p>
@@ -19470,9 +22440,9 @@
 </p:sld>
 </file>
 
-<file path=ppt/slides/slide41.xml><?xml version="1.0" encoding="utf-8"?>
+<file path=ppt/slides/slide47.xml><?xml version="1.0" encoding="utf-8"?>
 <p:sld xmlns:a="http://schemas.openxmlformats.org/drawingml/2006/main" xmlns:r="http://schemas.openxmlformats.org/officeDocument/2006/relationships" xmlns:p="http://schemas.openxmlformats.org/presentationml/2006/main">
-  <p:cSld name="Slide 41">
+  <p:cSld name="Slide 47">
     <p:spTree>
       <p:nvGrpSpPr>
         <p:cNvPr id="1" name=""/>

</xml_diff>